<commit_message>
feat(audit): audit simetri 18 slide, penyempurnaan header collision, layout slide 16, dan re-export
</commit_message>
<xml_diff>
--- a/bahan_paparan_walikota_v3/PAPARAN_WALIKOTA_STP_V9_18S.pptx
+++ b/bahan_paparan_walikota_v3/PAPARAN_WALIKOTA_STP_V9_18S.pptx
@@ -4596,8 +4596,8 @@
         </p:nvSpPr>
         <p:spPr>
           <a:xfrm>
-            <a:off x="731520" y="384048"/>
-            <a:ext cx="9144000" cy="219456"/>
+            <a:off x="731520" y="329184"/>
+            <a:ext cx="9144000" cy="201168"/>
           </a:xfrm>
           <a:prstGeom prst="rect">
             <a:avLst/>
@@ -4635,24 +4635,24 @@
         </p:nvSpPr>
         <p:spPr>
           <a:xfrm>
-            <a:off x="731520" y="594360"/>
-            <a:ext cx="9601200" cy="438912"/>
-          </a:xfrm>
-          <a:prstGeom prst="rect">
-            <a:avLst/>
-          </a:prstGeom>
-          <a:noFill/>
-          <a:ln/>
-        </p:spPr>
-        <p:txBody>
-          <a:bodyPr wrap="square" rtlCol="0" anchor="ctr"/>
-          <a:lstStyle/>
-          <a:p>
-            <a:pPr indent="0" marL="0">
-              <a:buNone/>
-            </a:pPr>
-            <a:r>
-              <a:rPr lang="en-US" sz="1900" b="1" dirty="0">
+            <a:off x="731520" y="566928"/>
+            <a:ext cx="9601200" cy="402336"/>
+          </a:xfrm>
+          <a:prstGeom prst="rect">
+            <a:avLst/>
+          </a:prstGeom>
+          <a:noFill/>
+          <a:ln/>
+        </p:spPr>
+        <p:txBody>
+          <a:bodyPr wrap="square" rtlCol="0" anchor="ctr"/>
+          <a:lstStyle/>
+          <a:p>
+            <a:pPr indent="0" marL="0">
+              <a:buNone/>
+            </a:pPr>
+            <a:r>
+              <a:rPr lang="en-US" sz="1850" b="1" dirty="0">
                 <a:solidFill>
                   <a:srgbClr val="0F172A"/>
                 </a:solidFill>
@@ -4662,7 +4662,7 @@
               </a:rPr>
               <a:t>LIMA SOLUSI TEROBOSAN STRATEGIS &amp; QUICK WINS 30 HARI</a:t>
             </a:r>
-            <a:endParaRPr lang="en-US" sz="1900" dirty="0"/>
+            <a:endParaRPr lang="en-US" sz="1850" dirty="0"/>
           </a:p>
         </p:txBody>
       </p:sp>
@@ -4674,24 +4674,24 @@
         </p:nvSpPr>
         <p:spPr>
           <a:xfrm>
-            <a:off x="731520" y="1024128"/>
-            <a:ext cx="9601200" cy="256032"/>
-          </a:xfrm>
-          <a:prstGeom prst="rect">
-            <a:avLst/>
-          </a:prstGeom>
-          <a:noFill/>
-          <a:ln/>
-        </p:spPr>
-        <p:txBody>
-          <a:bodyPr wrap="square" rtlCol="0" anchor="ctr"/>
-          <a:lstStyle/>
-          <a:p>
-            <a:pPr indent="0" marL="0">
-              <a:buNone/>
-            </a:pPr>
-            <a:r>
-              <a:rPr lang="en-US" sz="1050" i="1" dirty="0">
+            <a:off x="731520" y="1005840"/>
+            <a:ext cx="9601200" cy="237744"/>
+          </a:xfrm>
+          <a:prstGeom prst="rect">
+            <a:avLst/>
+          </a:prstGeom>
+          <a:noFill/>
+          <a:ln/>
+        </p:spPr>
+        <p:txBody>
+          <a:bodyPr wrap="square" rtlCol="0" anchor="ctr"/>
+          <a:lstStyle/>
+          <a:p>
+            <a:pPr indent="0" marL="0">
+              <a:buNone/>
+            </a:pPr>
+            <a:r>
+              <a:rPr lang="en-US" sz="1000" i="1" dirty="0">
                 <a:solidFill>
                   <a:srgbClr val="64748B"/>
                 </a:solidFill>
@@ -4701,7 +4701,7 @@
               </a:rPr>
               <a:t>Jawaban Konkret untuk Mengatasi 5 GAP Struktural Menuju Kemandirian Penuh BLUD 2030</a:t>
             </a:r>
-            <a:endParaRPr lang="en-US" sz="1050" dirty="0"/>
+            <a:endParaRPr lang="en-US" sz="1000" dirty="0"/>
           </a:p>
         </p:txBody>
       </p:sp>
@@ -4713,8 +4713,8 @@
         </p:nvSpPr>
         <p:spPr>
           <a:xfrm>
-            <a:off x="10515600" y="438912"/>
-            <a:ext cx="914400" cy="228600"/>
+            <a:off x="10515600" y="329184"/>
+            <a:ext cx="914400" cy="201168"/>
           </a:xfrm>
           <a:prstGeom prst="rect">
             <a:avLst/>
@@ -6198,8 +6198,8 @@
         </p:nvSpPr>
         <p:spPr>
           <a:xfrm>
-            <a:off x="731520" y="384048"/>
-            <a:ext cx="9144000" cy="219456"/>
+            <a:off x="731520" y="329184"/>
+            <a:ext cx="9144000" cy="201168"/>
           </a:xfrm>
           <a:prstGeom prst="rect">
             <a:avLst/>
@@ -6237,24 +6237,24 @@
         </p:nvSpPr>
         <p:spPr>
           <a:xfrm>
-            <a:off x="731520" y="594360"/>
-            <a:ext cx="9601200" cy="438912"/>
-          </a:xfrm>
-          <a:prstGeom prst="rect">
-            <a:avLst/>
-          </a:prstGeom>
-          <a:noFill/>
-          <a:ln/>
-        </p:spPr>
-        <p:txBody>
-          <a:bodyPr wrap="square" rtlCol="0" anchor="ctr"/>
-          <a:lstStyle/>
-          <a:p>
-            <a:pPr indent="0" marL="0">
-              <a:buNone/>
-            </a:pPr>
-            <a:r>
-              <a:rPr lang="en-US" sz="1900" b="1" dirty="0">
+            <a:off x="731520" y="566928"/>
+            <a:ext cx="9601200" cy="402336"/>
+          </a:xfrm>
+          <a:prstGeom prst="rect">
+            <a:avLst/>
+          </a:prstGeom>
+          <a:noFill/>
+          <a:ln/>
+        </p:spPr>
+        <p:txBody>
+          <a:bodyPr wrap="square" rtlCol="0" anchor="ctr"/>
+          <a:lstStyle/>
+          <a:p>
+            <a:pPr indent="0" marL="0">
+              <a:buNone/>
+            </a:pPr>
+            <a:r>
+              <a:rPr lang="en-US" sz="1850" b="1" dirty="0">
                 <a:solidFill>
                   <a:srgbClr val="0F172A"/>
                 </a:solidFill>
@@ -6264,7 +6264,7 @@
               </a:rPr>
               <a:t>TIGA FASE TRANSFORMASI SOLO TECHNOPARK (2026–2030)</a:t>
             </a:r>
-            <a:endParaRPr lang="en-US" sz="1900" dirty="0"/>
+            <a:endParaRPr lang="en-US" sz="1850" dirty="0"/>
           </a:p>
         </p:txBody>
       </p:sp>
@@ -6276,24 +6276,24 @@
         </p:nvSpPr>
         <p:spPr>
           <a:xfrm>
-            <a:off x="731520" y="1024128"/>
-            <a:ext cx="9601200" cy="256032"/>
-          </a:xfrm>
-          <a:prstGeom prst="rect">
-            <a:avLst/>
-          </a:prstGeom>
-          <a:noFill/>
-          <a:ln/>
-        </p:spPr>
-        <p:txBody>
-          <a:bodyPr wrap="square" rtlCol="0" anchor="ctr"/>
-          <a:lstStyle/>
-          <a:p>
-            <a:pPr indent="0" marL="0">
-              <a:buNone/>
-            </a:pPr>
-            <a:r>
-              <a:rPr lang="en-US" sz="1050" i="1" dirty="0">
+            <a:off x="731520" y="1005840"/>
+            <a:ext cx="9601200" cy="237744"/>
+          </a:xfrm>
+          <a:prstGeom prst="rect">
+            <a:avLst/>
+          </a:prstGeom>
+          <a:noFill/>
+          <a:ln/>
+        </p:spPr>
+        <p:txBody>
+          <a:bodyPr wrap="square" rtlCol="0" anchor="ctr"/>
+          <a:lstStyle/>
+          <a:p>
+            <a:pPr indent="0" marL="0">
+              <a:buNone/>
+            </a:pPr>
+            <a:r>
+              <a:rPr lang="en-US" sz="1000" i="1" dirty="0">
                 <a:solidFill>
                   <a:srgbClr val="64748B"/>
                 </a:solidFill>
@@ -6303,7 +6303,7 @@
               </a:rPr>
               <a:t>Tahapan Terukur Menuju Kemandirian Finansial Penuh dan Pengakuan sebagai Hub Inovasi Nasional</a:t>
             </a:r>
-            <a:endParaRPr lang="en-US" sz="1050" dirty="0"/>
+            <a:endParaRPr lang="en-US" sz="1000" dirty="0"/>
           </a:p>
         </p:txBody>
       </p:sp>
@@ -6315,8 +6315,8 @@
         </p:nvSpPr>
         <p:spPr>
           <a:xfrm>
-            <a:off x="10515600" y="438912"/>
-            <a:ext cx="914400" cy="228600"/>
+            <a:off x="10515600" y="329184"/>
+            <a:ext cx="914400" cy="201168"/>
           </a:xfrm>
           <a:prstGeom prst="rect">
             <a:avLst/>
@@ -8433,8 +8433,8 @@
         </p:nvSpPr>
         <p:spPr>
           <a:xfrm>
-            <a:off x="731520" y="384048"/>
-            <a:ext cx="9144000" cy="219456"/>
+            <a:off x="731520" y="329184"/>
+            <a:ext cx="9144000" cy="201168"/>
           </a:xfrm>
           <a:prstGeom prst="rect">
             <a:avLst/>
@@ -8472,24 +8472,24 @@
         </p:nvSpPr>
         <p:spPr>
           <a:xfrm>
-            <a:off x="731520" y="594360"/>
-            <a:ext cx="9601200" cy="438912"/>
-          </a:xfrm>
-          <a:prstGeom prst="rect">
-            <a:avLst/>
-          </a:prstGeom>
-          <a:noFill/>
-          <a:ln/>
-        </p:spPr>
-        <p:txBody>
-          <a:bodyPr wrap="square" rtlCol="0" anchor="ctr"/>
-          <a:lstStyle/>
-          <a:p>
-            <a:pPr indent="0" marL="0">
-              <a:buNone/>
-            </a:pPr>
-            <a:r>
-              <a:rPr lang="en-US" sz="1900" b="1" dirty="0">
+            <a:off x="731520" y="566928"/>
+            <a:ext cx="9601200" cy="402336"/>
+          </a:xfrm>
+          <a:prstGeom prst="rect">
+            <a:avLst/>
+          </a:prstGeom>
+          <a:noFill/>
+          <a:ln/>
+        </p:spPr>
+        <p:txBody>
+          <a:bodyPr wrap="square" rtlCol="0" anchor="ctr"/>
+          <a:lstStyle/>
+          <a:p>
+            <a:pPr indent="0" marL="0">
+              <a:buNone/>
+            </a:pPr>
+            <a:r>
+              <a:rPr lang="en-US" sz="1850" b="1" dirty="0">
                 <a:solidFill>
                   <a:srgbClr val="0F172A"/>
                 </a:solidFill>
@@ -8499,7 +8499,7 @@
               </a:rPr>
               <a:t>RE-SETTING TARGET PENDAPATAN BLUD MENUJU BEP 2029</a:t>
             </a:r>
-            <a:endParaRPr lang="en-US" sz="1900" dirty="0"/>
+            <a:endParaRPr lang="en-US" sz="1850" dirty="0"/>
           </a:p>
         </p:txBody>
       </p:sp>
@@ -8511,24 +8511,24 @@
         </p:nvSpPr>
         <p:spPr>
           <a:xfrm>
-            <a:off x="731520" y="1024128"/>
-            <a:ext cx="9601200" cy="256032"/>
-          </a:xfrm>
-          <a:prstGeom prst="rect">
-            <a:avLst/>
-          </a:prstGeom>
-          <a:noFill/>
-          <a:ln/>
-        </p:spPr>
-        <p:txBody>
-          <a:bodyPr wrap="square" rtlCol="0" anchor="ctr"/>
-          <a:lstStyle/>
-          <a:p>
-            <a:pPr indent="0" marL="0">
-              <a:buNone/>
-            </a:pPr>
-            <a:r>
-              <a:rPr lang="en-US" sz="1050" i="1" dirty="0">
+            <a:off x="731520" y="1005840"/>
+            <a:ext cx="9601200" cy="237744"/>
+          </a:xfrm>
+          <a:prstGeom prst="rect">
+            <a:avLst/>
+          </a:prstGeom>
+          <a:noFill/>
+          <a:ln/>
+        </p:spPr>
+        <p:txBody>
+          <a:bodyPr wrap="square" rtlCol="0" anchor="ctr"/>
+          <a:lstStyle/>
+          <a:p>
+            <a:pPr indent="0" marL="0">
+              <a:buNone/>
+            </a:pPr>
+            <a:r>
+              <a:rPr lang="en-US" sz="1000" i="1" dirty="0">
                 <a:solidFill>
                   <a:srgbClr val="64748B"/>
                 </a:solidFill>
@@ -8538,7 +8538,7 @@
               </a:rPr>
               <a:t>Lonjakan Pendapatan dari Rp 8,20 M (2026) Menuju Rp 23,47 M (2030) dengan Titik Impas di 2029</a:t>
             </a:r>
-            <a:endParaRPr lang="en-US" sz="1050" dirty="0"/>
+            <a:endParaRPr lang="en-US" sz="1000" dirty="0"/>
           </a:p>
         </p:txBody>
       </p:sp>
@@ -8550,8 +8550,8 @@
         </p:nvSpPr>
         <p:spPr>
           <a:xfrm>
-            <a:off x="10515600" y="438912"/>
-            <a:ext cx="914400" cy="228600"/>
+            <a:off x="10515600" y="329184"/>
+            <a:ext cx="914400" cy="201168"/>
           </a:xfrm>
           <a:prstGeom prst="rect">
             <a:avLst/>
@@ -9418,8 +9418,8 @@
         </p:nvSpPr>
         <p:spPr>
           <a:xfrm>
-            <a:off x="731520" y="384048"/>
-            <a:ext cx="9144000" cy="219456"/>
+            <a:off x="731520" y="329184"/>
+            <a:ext cx="9144000" cy="201168"/>
           </a:xfrm>
           <a:prstGeom prst="rect">
             <a:avLst/>
@@ -9457,24 +9457,24 @@
         </p:nvSpPr>
         <p:spPr>
           <a:xfrm>
-            <a:off x="731520" y="594360"/>
-            <a:ext cx="9601200" cy="438912"/>
-          </a:xfrm>
-          <a:prstGeom prst="rect">
-            <a:avLst/>
-          </a:prstGeom>
-          <a:noFill/>
-          <a:ln/>
-        </p:spPr>
-        <p:txBody>
-          <a:bodyPr wrap="square" rtlCol="0" anchor="ctr"/>
-          <a:lstStyle/>
-          <a:p>
-            <a:pPr indent="0" marL="0">
-              <a:buNone/>
-            </a:pPr>
-            <a:r>
-              <a:rPr lang="en-US" sz="1900" b="1" dirty="0">
+            <a:off x="731520" y="566928"/>
+            <a:ext cx="9601200" cy="402336"/>
+          </a:xfrm>
+          <a:prstGeom prst="rect">
+            <a:avLst/>
+          </a:prstGeom>
+          <a:noFill/>
+          <a:ln/>
+        </p:spPr>
+        <p:txBody>
+          <a:bodyPr wrap="square" rtlCol="0" anchor="ctr"/>
+          <a:lstStyle/>
+          <a:p>
+            <a:pPr indent="0" marL="0">
+              <a:buNone/>
+            </a:pPr>
+            <a:r>
+              <a:rPr lang="en-US" sz="1850" b="1" dirty="0">
                 <a:solidFill>
                   <a:srgbClr val="0F172A"/>
                 </a:solidFill>
@@ -9484,7 +9484,7 @@
               </a:rPr>
               <a:t>KOMPOSISI 6 KLASTER PENDAPATAN &amp; TOP 5 KATALISATOR</a:t>
             </a:r>
-            <a:endParaRPr lang="en-US" sz="1900" dirty="0"/>
+            <a:endParaRPr lang="en-US" sz="1850" dirty="0"/>
           </a:p>
         </p:txBody>
       </p:sp>
@@ -9496,24 +9496,24 @@
         </p:nvSpPr>
         <p:spPr>
           <a:xfrm>
-            <a:off x="731520" y="1024128"/>
-            <a:ext cx="9601200" cy="256032"/>
-          </a:xfrm>
-          <a:prstGeom prst="rect">
-            <a:avLst/>
-          </a:prstGeom>
-          <a:noFill/>
-          <a:ln/>
-        </p:spPr>
-        <p:txBody>
-          <a:bodyPr wrap="square" rtlCol="0" anchor="ctr"/>
-          <a:lstStyle/>
-          <a:p>
-            <a:pPr indent="0" marL="0">
-              <a:buNone/>
-            </a:pPr>
-            <a:r>
-              <a:rPr lang="en-US" sz="1050" i="1" dirty="0">
+            <a:off x="731520" y="1005840"/>
+            <a:ext cx="9601200" cy="237744"/>
+          </a:xfrm>
+          <a:prstGeom prst="rect">
+            <a:avLst/>
+          </a:prstGeom>
+          <a:noFill/>
+          <a:ln/>
+        </p:spPr>
+        <p:txBody>
+          <a:bodyPr wrap="square" rtlCol="0" anchor="ctr"/>
+          <a:lstStyle/>
+          <a:p>
+            <a:pPr indent="0" marL="0">
+              <a:buNone/>
+            </a:pPr>
+            <a:r>
+              <a:rPr lang="en-US" sz="1000" i="1" dirty="0">
                 <a:solidFill>
                   <a:srgbClr val="64748B"/>
                 </a:solidFill>
@@ -9523,7 +9523,7 @@
               </a:rPr>
               <a:t>Diversifikasi Sumber Penerimaan untuk Memastikan Stabilitas Keuangan Tanpa Ketergantungan Tunggal</a:t>
             </a:r>
-            <a:endParaRPr lang="en-US" sz="1050" dirty="0"/>
+            <a:endParaRPr lang="en-US" sz="1000" dirty="0"/>
           </a:p>
         </p:txBody>
       </p:sp>
@@ -9535,8 +9535,8 @@
         </p:nvSpPr>
         <p:spPr>
           <a:xfrm>
-            <a:off x="10515600" y="438912"/>
-            <a:ext cx="914400" cy="228600"/>
+            <a:off x="10515600" y="329184"/>
+            <a:ext cx="914400" cy="201168"/>
           </a:xfrm>
           <a:prstGeom prst="rect">
             <a:avLst/>
@@ -10981,8 +10981,8 @@
         </p:nvSpPr>
         <p:spPr>
           <a:xfrm>
-            <a:off x="731520" y="384048"/>
-            <a:ext cx="9144000" cy="219456"/>
+            <a:off x="731520" y="329184"/>
+            <a:ext cx="9144000" cy="201168"/>
           </a:xfrm>
           <a:prstGeom prst="rect">
             <a:avLst/>
@@ -11020,24 +11020,24 @@
         </p:nvSpPr>
         <p:spPr>
           <a:xfrm>
-            <a:off x="731520" y="594360"/>
-            <a:ext cx="9601200" cy="438912"/>
-          </a:xfrm>
-          <a:prstGeom prst="rect">
-            <a:avLst/>
-          </a:prstGeom>
-          <a:noFill/>
-          <a:ln/>
-        </p:spPr>
-        <p:txBody>
-          <a:bodyPr wrap="square" rtlCol="0" anchor="ctr"/>
-          <a:lstStyle/>
-          <a:p>
-            <a:pPr indent="0" marL="0">
-              <a:buNone/>
-            </a:pPr>
-            <a:r>
-              <a:rPr lang="en-US" sz="1900" b="1" dirty="0">
+            <a:off x="731520" y="566928"/>
+            <a:ext cx="9601200" cy="402336"/>
+          </a:xfrm>
+          <a:prstGeom prst="rect">
+            <a:avLst/>
+          </a:prstGeom>
+          <a:noFill/>
+          <a:ln/>
+        </p:spPr>
+        <p:txBody>
+          <a:bodyPr wrap="square" rtlCol="0" anchor="ctr"/>
+          <a:lstStyle/>
+          <a:p>
+            <a:pPr indent="0" marL="0">
+              <a:buNone/>
+            </a:pPr>
+            <a:r>
+              <a:rPr lang="en-US" sz="1850" b="1" dirty="0">
                 <a:solidFill>
                   <a:srgbClr val="0F172A"/>
                 </a:solidFill>
@@ -11047,7 +11047,7 @@
               </a:rPr>
               <a:t>ANATOMI KLASTER A: KERJASAMA PEMANFAATAN LAHAN &amp; ASET</a:t>
             </a:r>
-            <a:endParaRPr lang="en-US" sz="1900" dirty="0"/>
+            <a:endParaRPr lang="en-US" sz="1850" dirty="0"/>
           </a:p>
         </p:txBody>
       </p:sp>
@@ -11059,24 +11059,24 @@
         </p:nvSpPr>
         <p:spPr>
           <a:xfrm>
-            <a:off x="731520" y="1024128"/>
-            <a:ext cx="9601200" cy="256032"/>
-          </a:xfrm>
-          <a:prstGeom prst="rect">
-            <a:avLst/>
-          </a:prstGeom>
-          <a:noFill/>
-          <a:ln/>
-        </p:spPr>
-        <p:txBody>
-          <a:bodyPr wrap="square" rtlCol="0" anchor="ctr"/>
-          <a:lstStyle/>
-          <a:p>
-            <a:pPr indent="0" marL="0">
-              <a:buNone/>
-            </a:pPr>
-            <a:r>
-              <a:rPr lang="en-US" sz="1050" i="1" dirty="0">
+            <a:off x="731520" y="1005840"/>
+            <a:ext cx="9601200" cy="237744"/>
+          </a:xfrm>
+          <a:prstGeom prst="rect">
+            <a:avLst/>
+          </a:prstGeom>
+          <a:noFill/>
+          <a:ln/>
+        </p:spPr>
+        <p:txBody>
+          <a:bodyPr wrap="square" rtlCol="0" anchor="ctr"/>
+          <a:lstStyle/>
+          <a:p>
+            <a:pPr indent="0" marL="0">
+              <a:buNone/>
+            </a:pPr>
+            <a:r>
+              <a:rPr lang="en-US" sz="1000" i="1" dirty="0">
                 <a:solidFill>
                   <a:srgbClr val="64748B"/>
                 </a:solidFill>
@@ -11086,7 +11086,7 @@
               </a:rPr>
               <a:t>Sumber Pendapatan Jangkar Senilai Rp 12.825.000.000 (54,6% dari Total Target Mandiri 2030)</a:t>
             </a:r>
-            <a:endParaRPr lang="en-US" sz="1050" dirty="0"/>
+            <a:endParaRPr lang="en-US" sz="1000" dirty="0"/>
           </a:p>
         </p:txBody>
       </p:sp>
@@ -11098,8 +11098,8 @@
         </p:nvSpPr>
         <p:spPr>
           <a:xfrm>
-            <a:off x="10515600" y="438912"/>
-            <a:ext cx="914400" cy="228600"/>
+            <a:off x="10515600" y="329184"/>
+            <a:ext cx="914400" cy="201168"/>
           </a:xfrm>
           <a:prstGeom prst="rect">
             <a:avLst/>
@@ -12691,8 +12691,8 @@
         </p:nvSpPr>
         <p:spPr>
           <a:xfrm>
-            <a:off x="731520" y="384048"/>
-            <a:ext cx="9144000" cy="219456"/>
+            <a:off x="731520" y="329184"/>
+            <a:ext cx="9144000" cy="201168"/>
           </a:xfrm>
           <a:prstGeom prst="rect">
             <a:avLst/>
@@ -12730,24 +12730,24 @@
         </p:nvSpPr>
         <p:spPr>
           <a:xfrm>
-            <a:off x="731520" y="594360"/>
-            <a:ext cx="9601200" cy="438912"/>
-          </a:xfrm>
-          <a:prstGeom prst="rect">
-            <a:avLst/>
-          </a:prstGeom>
-          <a:noFill/>
-          <a:ln/>
-        </p:spPr>
-        <p:txBody>
-          <a:bodyPr wrap="square" rtlCol="0" anchor="ctr"/>
-          <a:lstStyle/>
-          <a:p>
-            <a:pPr indent="0" marL="0">
-              <a:buNone/>
-            </a:pPr>
-            <a:r>
-              <a:rPr lang="en-US" sz="1900" b="1" dirty="0">
+            <a:off x="731520" y="566928"/>
+            <a:ext cx="9601200" cy="402336"/>
+          </a:xfrm>
+          <a:prstGeom prst="rect">
+            <a:avLst/>
+          </a:prstGeom>
+          <a:noFill/>
+          <a:ln/>
+        </p:spPr>
+        <p:txBody>
+          <a:bodyPr wrap="square" rtlCol="0" anchor="ctr"/>
+          <a:lstStyle/>
+          <a:p>
+            <a:pPr indent="0" marL="0">
+              <a:buNone/>
+            </a:pPr>
+            <a:r>
+              <a:rPr lang="en-US" sz="1850" b="1" dirty="0">
                 <a:solidFill>
                   <a:srgbClr val="0F172A"/>
                 </a:solidFill>
@@ -12757,7 +12757,7 @@
               </a:rPr>
               <a:t>ANATOMI KLASTER B–F: LAYANAN INOVASI &amp; JASA TEKNOLOGI</a:t>
             </a:r>
-            <a:endParaRPr lang="en-US" sz="1900" dirty="0"/>
+            <a:endParaRPr lang="en-US" sz="1850" dirty="0"/>
           </a:p>
         </p:txBody>
       </p:sp>
@@ -12769,24 +12769,24 @@
         </p:nvSpPr>
         <p:spPr>
           <a:xfrm>
-            <a:off x="731520" y="1024128"/>
-            <a:ext cx="9601200" cy="256032"/>
-          </a:xfrm>
-          <a:prstGeom prst="rect">
-            <a:avLst/>
-          </a:prstGeom>
-          <a:noFill/>
-          <a:ln/>
-        </p:spPr>
-        <p:txBody>
-          <a:bodyPr wrap="square" rtlCol="0" anchor="ctr"/>
-          <a:lstStyle/>
-          <a:p>
-            <a:pPr indent="0" marL="0">
-              <a:buNone/>
-            </a:pPr>
-            <a:r>
-              <a:rPr lang="en-US" sz="1050" i="1" dirty="0">
+            <a:off x="731520" y="1005840"/>
+            <a:ext cx="9601200" cy="237744"/>
+          </a:xfrm>
+          <a:prstGeom prst="rect">
+            <a:avLst/>
+          </a:prstGeom>
+          <a:noFill/>
+          <a:ln/>
+        </p:spPr>
+        <p:txBody>
+          <a:bodyPr wrap="square" rtlCol="0" anchor="ctr"/>
+          <a:lstStyle/>
+          <a:p>
+            <a:pPr indent="0" marL="0">
+              <a:buNone/>
+            </a:pPr>
+            <a:r>
+              <a:rPr lang="en-US" sz="1000" i="1" dirty="0">
                 <a:solidFill>
                   <a:srgbClr val="64748B"/>
                 </a:solidFill>
@@ -12796,7 +12796,7 @@
               </a:rPr>
               <a:t>Pendapatan Berbasis Jasa, Sertifikasi, dan Pengujian Senilai Rp 10.643.158.831 (45,4% dari Total Target)</a:t>
             </a:r>
-            <a:endParaRPr lang="en-US" sz="1050" dirty="0"/>
+            <a:endParaRPr lang="en-US" sz="1000" dirty="0"/>
           </a:p>
         </p:txBody>
       </p:sp>
@@ -12808,8 +12808,8 @@
         </p:nvSpPr>
         <p:spPr>
           <a:xfrm>
-            <a:off x="10515600" y="438912"/>
-            <a:ext cx="914400" cy="228600"/>
+            <a:off x="10515600" y="329184"/>
+            <a:ext cx="914400" cy="201168"/>
           </a:xfrm>
           <a:prstGeom prst="rect">
             <a:avLst/>
@@ -14315,8 +14315,8 @@
         </p:nvSpPr>
         <p:spPr>
           <a:xfrm>
-            <a:off x="731520" y="384048"/>
-            <a:ext cx="9144000" cy="219456"/>
+            <a:off x="731520" y="329184"/>
+            <a:ext cx="9144000" cy="201168"/>
           </a:xfrm>
           <a:prstGeom prst="rect">
             <a:avLst/>
@@ -14354,24 +14354,24 @@
         </p:nvSpPr>
         <p:spPr>
           <a:xfrm>
-            <a:off x="731520" y="594360"/>
-            <a:ext cx="9601200" cy="438912"/>
-          </a:xfrm>
-          <a:prstGeom prst="rect">
-            <a:avLst/>
-          </a:prstGeom>
-          <a:noFill/>
-          <a:ln/>
-        </p:spPr>
-        <p:txBody>
-          <a:bodyPr wrap="square" rtlCol="0" anchor="ctr"/>
-          <a:lstStyle/>
-          <a:p>
-            <a:pPr indent="0" marL="0">
-              <a:buNone/>
-            </a:pPr>
-            <a:r>
-              <a:rPr lang="en-US" sz="1900" b="1" dirty="0">
+            <a:off x="731520" y="566928"/>
+            <a:ext cx="9601200" cy="402336"/>
+          </a:xfrm>
+          <a:prstGeom prst="rect">
+            <a:avLst/>
+          </a:prstGeom>
+          <a:noFill/>
+          <a:ln/>
+        </p:spPr>
+        <p:txBody>
+          <a:bodyPr wrap="square" rtlCol="0" anchor="ctr"/>
+          <a:lstStyle/>
+          <a:p>
+            <a:pPr indent="0" marL="0">
+              <a:buNone/>
+            </a:pPr>
+            <a:r>
+              <a:rPr lang="en-US" sz="1850" b="1" dirty="0">
                 <a:solidFill>
                   <a:srgbClr val="0F172A"/>
                 </a:solidFill>
@@ -14381,7 +14381,7 @@
               </a:rPr>
               <a:t>ENAM DIMENSI DAMPAK SOLO TECHNOPARK UNTUK KOTA SURAKARTA</a:t>
             </a:r>
-            <a:endParaRPr lang="en-US" sz="1900" dirty="0"/>
+            <a:endParaRPr lang="en-US" sz="1850" dirty="0"/>
           </a:p>
         </p:txBody>
       </p:sp>
@@ -14393,24 +14393,24 @@
         </p:nvSpPr>
         <p:spPr>
           <a:xfrm>
-            <a:off x="731520" y="1024128"/>
-            <a:ext cx="9601200" cy="256032"/>
-          </a:xfrm>
-          <a:prstGeom prst="rect">
-            <a:avLst/>
-          </a:prstGeom>
-          <a:noFill/>
-          <a:ln/>
-        </p:spPr>
-        <p:txBody>
-          <a:bodyPr wrap="square" rtlCol="0" anchor="ctr"/>
-          <a:lstStyle/>
-          <a:p>
-            <a:pPr indent="0" marL="0">
-              <a:buNone/>
-            </a:pPr>
-            <a:r>
-              <a:rPr lang="en-US" sz="1050" i="1" dirty="0">
+            <a:off x="731520" y="1005840"/>
+            <a:ext cx="9601200" cy="237744"/>
+          </a:xfrm>
+          <a:prstGeom prst="rect">
+            <a:avLst/>
+          </a:prstGeom>
+          <a:noFill/>
+          <a:ln/>
+        </p:spPr>
+        <p:txBody>
+          <a:bodyPr wrap="square" rtlCol="0" anchor="ctr"/>
+          <a:lstStyle/>
+          <a:p>
+            <a:pPr indent="0" marL="0">
+              <a:buNone/>
+            </a:pPr>
+            <a:r>
+              <a:rPr lang="en-US" sz="1000" i="1" dirty="0">
                 <a:solidFill>
                   <a:srgbClr val="64748B"/>
                 </a:solidFill>
@@ -14420,7 +14420,7 @@
               </a:rPr>
               <a:t>Parameter Kuantitatif dan Kualitatif Keberhasilan Pembangunan Ekosistem Inovasi 2026–2030</a:t>
             </a:r>
-            <a:endParaRPr lang="en-US" sz="1050" dirty="0"/>
+            <a:endParaRPr lang="en-US" sz="1000" dirty="0"/>
           </a:p>
         </p:txBody>
       </p:sp>
@@ -14432,8 +14432,8 @@
         </p:nvSpPr>
         <p:spPr>
           <a:xfrm>
-            <a:off x="10515600" y="438912"/>
-            <a:ext cx="914400" cy="228600"/>
+            <a:off x="10515600" y="329184"/>
+            <a:ext cx="914400" cy="201168"/>
           </a:xfrm>
           <a:prstGeom prst="rect">
             <a:avLst/>
@@ -14545,7 +14545,7 @@
         <p:spPr>
           <a:xfrm>
             <a:off x="914400" y="1655064"/>
-            <a:ext cx="438912" cy="438912"/>
+            <a:ext cx="420624" cy="420624"/>
           </a:xfrm>
           <a:prstGeom prst="rect">
             <a:avLst/>
@@ -14584,7 +14584,7 @@
         <p:spPr>
           <a:xfrm>
             <a:off x="987552" y="1728216"/>
-            <a:ext cx="292608" cy="292608"/>
+            <a:ext cx="274320" cy="274320"/>
           </a:xfrm>
           <a:prstGeom prst="rect">
             <a:avLst/>
@@ -14599,24 +14599,24 @@
         </p:nvSpPr>
         <p:spPr>
           <a:xfrm>
-            <a:off x="1325880" y="1655064"/>
-            <a:ext cx="2651760" cy="228600"/>
-          </a:xfrm>
-          <a:prstGeom prst="rect">
-            <a:avLst/>
-          </a:prstGeom>
-          <a:noFill/>
-          <a:ln/>
-        </p:spPr>
-        <p:txBody>
-          <a:bodyPr wrap="square" rtlCol="0" anchor="ctr"/>
-          <a:lstStyle/>
-          <a:p>
-            <a:pPr indent="0" marL="0">
-              <a:buNone/>
-            </a:pPr>
-            <a:r>
-              <a:rPr lang="en-US" sz="1000" b="1" dirty="0">
+            <a:off x="1280160" y="1655064"/>
+            <a:ext cx="1554480" cy="219456"/>
+          </a:xfrm>
+          <a:prstGeom prst="rect">
+            <a:avLst/>
+          </a:prstGeom>
+          <a:noFill/>
+          <a:ln/>
+        </p:spPr>
+        <p:txBody>
+          <a:bodyPr wrap="square" rtlCol="0" anchor="ctr"/>
+          <a:lstStyle/>
+          <a:p>
+            <a:pPr indent="0" marL="0">
+              <a:buNone/>
+            </a:pPr>
+            <a:r>
+              <a:rPr lang="en-US" sz="950" b="1" dirty="0">
                 <a:solidFill>
                   <a:srgbClr val="0F172A"/>
                 </a:solidFill>
@@ -14624,61 +14624,22 @@
                 <a:ea typeface="Arial" pitchFamily="34" charset="-122"/>
                 <a:cs typeface="Arial" pitchFamily="34" charset="-120"/>
               </a:rPr>
-              <a:t>1. DAMPAK EKONOMI DAERAH</a:t>
-            </a:r>
-            <a:endParaRPr lang="en-US" sz="1000" dirty="0"/>
-          </a:p>
-        </p:txBody>
-      </p:sp>
-      <p:sp>
-        <p:nvSpPr>
-          <p:cNvPr id="12" name="Text 9"/>
-          <p:cNvSpPr/>
-          <p:nvPr/>
-        </p:nvSpPr>
-        <p:spPr>
-          <a:xfrm>
-            <a:off x="914400" y="2011680"/>
-            <a:ext cx="2011680" cy="347472"/>
-          </a:xfrm>
-          <a:prstGeom prst="rect">
-            <a:avLst/>
-          </a:prstGeom>
-          <a:noFill/>
-          <a:ln/>
-        </p:spPr>
-        <p:txBody>
-          <a:bodyPr wrap="square" rtlCol="0" anchor="ctr"/>
-          <a:lstStyle/>
-          <a:p>
-            <a:pPr indent="0" marL="0">
-              <a:buNone/>
-            </a:pPr>
-            <a:r>
-              <a:rPr lang="en-US" sz="1700" b="1" dirty="0">
-                <a:solidFill>
-                  <a:srgbClr val="1E3A8A"/>
-                </a:solidFill>
-                <a:latin typeface="Arial" pitchFamily="34" charset="0"/>
-                <a:ea typeface="Arial" pitchFamily="34" charset="-122"/>
-                <a:cs typeface="Arial" pitchFamily="34" charset="-120"/>
-              </a:rPr>
-              <a:t>Rp 18,5 Miliar</a:t>
-            </a:r>
-            <a:endParaRPr lang="en-US" sz="1700" dirty="0"/>
-          </a:p>
-        </p:txBody>
-      </p:sp>
-      <p:sp>
-        <p:nvSpPr>
-          <p:cNvPr id="13" name="Shape 10"/>
-          <p:cNvSpPr/>
-          <p:nvPr/>
-        </p:nvSpPr>
-        <p:spPr>
-          <a:xfrm>
-            <a:off x="2880360" y="2057400"/>
-            <a:ext cx="1143000" cy="219456"/>
+              <a:t>1. DAMPAK EKONOMI</a:t>
+            </a:r>
+            <a:endParaRPr lang="en-US" sz="950" dirty="0"/>
+          </a:p>
+        </p:txBody>
+      </p:sp>
+      <p:sp>
+        <p:nvSpPr>
+          <p:cNvPr id="12" name="Shape 9"/>
+          <p:cNvSpPr/>
+          <p:nvPr/>
+        </p:nvSpPr>
+        <p:spPr>
+          <a:xfrm>
+            <a:off x="2889504" y="1655064"/>
+            <a:ext cx="1115568" cy="219456"/>
           </a:xfrm>
           <a:prstGeom prst="rect">
             <a:avLst/>
@@ -14696,14 +14657,14 @@
       </p:sp>
       <p:sp>
         <p:nvSpPr>
-          <p:cNvPr id="14" name="Text 11"/>
-          <p:cNvSpPr/>
-          <p:nvPr/>
-        </p:nvSpPr>
-        <p:spPr>
-          <a:xfrm>
-            <a:off x="2880360" y="2075688"/>
-            <a:ext cx="1143000" cy="182880"/>
+          <p:cNvPr id="13" name="Text 10"/>
+          <p:cNvSpPr/>
+          <p:nvPr/>
+        </p:nvSpPr>
+        <p:spPr>
+          <a:xfrm>
+            <a:off x="2889504" y="1673352"/>
+            <a:ext cx="1115568" cy="182880"/>
           </a:xfrm>
           <a:prstGeom prst="rect">
             <a:avLst/>
@@ -14719,7 +14680,7 @@
               <a:buNone/>
             </a:pPr>
             <a:r>
-              <a:rPr lang="en-US" sz="700" b="1" dirty="0">
+              <a:rPr lang="en-US" sz="750" b="1" dirty="0">
                 <a:solidFill>
                   <a:srgbClr val="1E3A8A"/>
                 </a:solidFill>
@@ -14727,45 +14688,84 @@
                 <a:ea typeface="Arial" pitchFamily="34" charset="-122"/>
                 <a:cs typeface="Arial" pitchFamily="34" charset="-120"/>
               </a:rPr>
-              <a:t>+300% MULTIPLIER EFFECT</a:t>
-            </a:r>
-            <a:endParaRPr lang="en-US" sz="700" dirty="0"/>
-          </a:p>
-        </p:txBody>
-      </p:sp>
-      <p:sp>
-        <p:nvSpPr>
-          <p:cNvPr id="15" name="Text 12"/>
-          <p:cNvSpPr/>
-          <p:nvPr/>
-        </p:nvSpPr>
-        <p:spPr>
-          <a:xfrm>
-            <a:off x="914400" y="2377440"/>
-            <a:ext cx="3090672" cy="201168"/>
-          </a:xfrm>
-          <a:prstGeom prst="rect">
-            <a:avLst/>
-          </a:prstGeom>
-          <a:noFill/>
-          <a:ln/>
-        </p:spPr>
-        <p:txBody>
-          <a:bodyPr wrap="square" rtlCol="0" anchor="ctr"/>
-          <a:lstStyle/>
-          <a:p>
-            <a:pPr indent="0" marL="0">
-              <a:buNone/>
-            </a:pPr>
-            <a:r>
-              <a:rPr lang="en-US" sz="850" b="1" dirty="0">
-                <a:solidFill>
-                  <a:srgbClr val="64748B"/>
+              <a:t>+300% MULTIPLIER</a:t>
+            </a:r>
+            <a:endParaRPr lang="en-US" sz="750" dirty="0"/>
+          </a:p>
+        </p:txBody>
+      </p:sp>
+      <p:sp>
+        <p:nvSpPr>
+          <p:cNvPr id="14" name="Text 11"/>
+          <p:cNvSpPr/>
+          <p:nvPr/>
+        </p:nvSpPr>
+        <p:spPr>
+          <a:xfrm>
+            <a:off x="914400" y="1984248"/>
+            <a:ext cx="3090672" cy="329184"/>
+          </a:xfrm>
+          <a:prstGeom prst="rect">
+            <a:avLst/>
+          </a:prstGeom>
+          <a:noFill/>
+          <a:ln/>
+        </p:spPr>
+        <p:txBody>
+          <a:bodyPr wrap="square" rtlCol="0" anchor="ctr"/>
+          <a:lstStyle/>
+          <a:p>
+            <a:pPr indent="0" marL="0">
+              <a:buNone/>
+            </a:pPr>
+            <a:r>
+              <a:rPr lang="en-US" sz="1650" b="1" dirty="0">
+                <a:solidFill>
+                  <a:srgbClr val="1E3A8A"/>
                 </a:solidFill>
                 <a:latin typeface="Arial" pitchFamily="34" charset="0"/>
                 <a:ea typeface="Arial" pitchFamily="34" charset="-122"/>
                 <a:cs typeface="Arial" pitchFamily="34" charset="-120"/>
               </a:rPr>
+              <a:t>Rp 18,5 Miliar</a:t>
+            </a:r>
+            <a:endParaRPr lang="en-US" sz="1650" dirty="0"/>
+          </a:p>
+        </p:txBody>
+      </p:sp>
+      <p:sp>
+        <p:nvSpPr>
+          <p:cNvPr id="15" name="Text 12"/>
+          <p:cNvSpPr/>
+          <p:nvPr/>
+        </p:nvSpPr>
+        <p:spPr>
+          <a:xfrm>
+            <a:off x="914400" y="2331720"/>
+            <a:ext cx="3090672" cy="201168"/>
+          </a:xfrm>
+          <a:prstGeom prst="rect">
+            <a:avLst/>
+          </a:prstGeom>
+          <a:noFill/>
+          <a:ln/>
+        </p:spPr>
+        <p:txBody>
+          <a:bodyPr wrap="square" rtlCol="0" anchor="ctr"/>
+          <a:lstStyle/>
+          <a:p>
+            <a:pPr indent="0" marL="0">
+              <a:buNone/>
+            </a:pPr>
+            <a:r>
+              <a:rPr lang="en-US" sz="850" b="1" dirty="0">
+                <a:solidFill>
+                  <a:srgbClr val="64748B"/>
+                </a:solidFill>
+                <a:latin typeface="Arial" pitchFamily="34" charset="0"/>
+                <a:ea typeface="Arial" pitchFamily="34" charset="-122"/>
+                <a:cs typeface="Arial" pitchFamily="34" charset="-120"/>
+              </a:rPr>
               <a:t>Omzet Komulatif Tenant Inovasi 2030</a:t>
             </a:r>
             <a:endParaRPr lang="en-US" sz="850" dirty="0"/>
@@ -14780,7 +14780,7 @@
         </p:nvSpPr>
         <p:spPr>
           <a:xfrm>
-            <a:off x="914400" y="2624328"/>
+            <a:off x="914400" y="2569464"/>
             <a:ext cx="3090672" cy="0"/>
           </a:xfrm>
           <a:prstGeom prst="line">
@@ -14803,8 +14803,8 @@
         </p:nvSpPr>
         <p:spPr>
           <a:xfrm>
-            <a:off x="914400" y="2697480"/>
-            <a:ext cx="3090672" cy="685800"/>
+            <a:off x="914400" y="2642616"/>
+            <a:ext cx="3090672" cy="713232"/>
           </a:xfrm>
           <a:prstGeom prst="rect">
             <a:avLst/>
@@ -14818,12 +14818,12 @@
           <a:p>
             <a:pPr indent="0" marL="0">
               <a:lnSpc>
-                <a:spcPct val="120000"/>
+                <a:spcPct val="118000"/>
               </a:lnSpc>
               <a:buNone/>
             </a:pPr>
             <a:r>
-              <a:rPr lang="en-US" sz="1000" dirty="0">
+              <a:rPr lang="en-US" sz="950" dirty="0">
                 <a:solidFill>
                   <a:srgbClr val="475569"/>
                 </a:solidFill>
@@ -14833,7 +14833,7 @@
               </a:rPr>
               <a:t>Menciptakan perputaran ekonomi baru di Surakarta melalui komersialisasi produk inovasi teknologi dan pembentukan startup lokal.</a:t>
             </a:r>
-            <a:endParaRPr lang="en-US" sz="1000" dirty="0"/>
+            <a:endParaRPr lang="en-US" sz="950" dirty="0"/>
           </a:p>
         </p:txBody>
       </p:sp>
@@ -14896,7 +14896,7 @@
         <p:spPr>
           <a:xfrm>
             <a:off x="4553712" y="1655064"/>
-            <a:ext cx="438912" cy="438912"/>
+            <a:ext cx="420624" cy="420624"/>
           </a:xfrm>
           <a:prstGeom prst="rect">
             <a:avLst/>
@@ -14935,7 +14935,7 @@
         <p:spPr>
           <a:xfrm>
             <a:off x="4626864" y="1728216"/>
-            <a:ext cx="292608" cy="292608"/>
+            <a:ext cx="274320" cy="274320"/>
           </a:xfrm>
           <a:prstGeom prst="rect">
             <a:avLst/>
@@ -14950,24 +14950,24 @@
         </p:nvSpPr>
         <p:spPr>
           <a:xfrm>
-            <a:off x="4965192" y="1655064"/>
-            <a:ext cx="2651760" cy="228600"/>
-          </a:xfrm>
-          <a:prstGeom prst="rect">
-            <a:avLst/>
-          </a:prstGeom>
-          <a:noFill/>
-          <a:ln/>
-        </p:spPr>
-        <p:txBody>
-          <a:bodyPr wrap="square" rtlCol="0" anchor="ctr"/>
-          <a:lstStyle/>
-          <a:p>
-            <a:pPr indent="0" marL="0">
-              <a:buNone/>
-            </a:pPr>
-            <a:r>
-              <a:rPr lang="en-US" sz="1000" b="1" dirty="0">
+            <a:off x="4919472" y="1655064"/>
+            <a:ext cx="1554480" cy="219456"/>
+          </a:xfrm>
+          <a:prstGeom prst="rect">
+            <a:avLst/>
+          </a:prstGeom>
+          <a:noFill/>
+          <a:ln/>
+        </p:spPr>
+        <p:txBody>
+          <a:bodyPr wrap="square" rtlCol="0" anchor="ctr"/>
+          <a:lstStyle/>
+          <a:p>
+            <a:pPr indent="0" marL="0">
+              <a:buNone/>
+            </a:pPr>
+            <a:r>
+              <a:rPr lang="en-US" sz="950" b="1" dirty="0">
                 <a:solidFill>
                   <a:srgbClr val="0F172A"/>
                 </a:solidFill>
@@ -14975,61 +14975,22 @@
                 <a:ea typeface="Arial" pitchFamily="34" charset="-122"/>
                 <a:cs typeface="Arial" pitchFamily="34" charset="-120"/>
               </a:rPr>
-              <a:t>2. SERAPAN TENAGA KERJA</a:t>
-            </a:r>
-            <a:endParaRPr lang="en-US" sz="1000" dirty="0"/>
-          </a:p>
-        </p:txBody>
-      </p:sp>
-      <p:sp>
-        <p:nvSpPr>
-          <p:cNvPr id="23" name="Text 19"/>
-          <p:cNvSpPr/>
-          <p:nvPr/>
-        </p:nvSpPr>
-        <p:spPr>
-          <a:xfrm>
-            <a:off x="4553712" y="2011680"/>
-            <a:ext cx="2011680" cy="347472"/>
-          </a:xfrm>
-          <a:prstGeom prst="rect">
-            <a:avLst/>
-          </a:prstGeom>
-          <a:noFill/>
-          <a:ln/>
-        </p:spPr>
-        <p:txBody>
-          <a:bodyPr wrap="square" rtlCol="0" anchor="ctr"/>
-          <a:lstStyle/>
-          <a:p>
-            <a:pPr indent="0" marL="0">
-              <a:buNone/>
-            </a:pPr>
-            <a:r>
-              <a:rPr lang="en-US" sz="1700" b="1" dirty="0">
-                <a:solidFill>
-                  <a:srgbClr val="1E40AF"/>
-                </a:solidFill>
-                <a:latin typeface="Arial" pitchFamily="34" charset="0"/>
-                <a:ea typeface="Arial" pitchFamily="34" charset="-122"/>
-                <a:cs typeface="Arial" pitchFamily="34" charset="-120"/>
-              </a:rPr>
-              <a:t>1.500 Talenta / Thn</a:t>
-            </a:r>
-            <a:endParaRPr lang="en-US" sz="1700" dirty="0"/>
-          </a:p>
-        </p:txBody>
-      </p:sp>
-      <p:sp>
-        <p:nvSpPr>
-          <p:cNvPr id="24" name="Shape 20"/>
-          <p:cNvSpPr/>
-          <p:nvPr/>
-        </p:nvSpPr>
-        <p:spPr>
-          <a:xfrm>
-            <a:off x="6519672" y="2057400"/>
-            <a:ext cx="1143000" cy="219456"/>
+              <a:t>2. SERAPAN KERJA</a:t>
+            </a:r>
+            <a:endParaRPr lang="en-US" sz="950" dirty="0"/>
+          </a:p>
+        </p:txBody>
+      </p:sp>
+      <p:sp>
+        <p:nvSpPr>
+          <p:cNvPr id="23" name="Shape 19"/>
+          <p:cNvSpPr/>
+          <p:nvPr/>
+        </p:nvSpPr>
+        <p:spPr>
+          <a:xfrm>
+            <a:off x="6528816" y="1655064"/>
+            <a:ext cx="1115568" cy="219456"/>
           </a:xfrm>
           <a:prstGeom prst="rect">
             <a:avLst/>
@@ -15047,14 +15008,14 @@
       </p:sp>
       <p:sp>
         <p:nvSpPr>
-          <p:cNvPr id="25" name="Text 21"/>
-          <p:cNvSpPr/>
-          <p:nvPr/>
-        </p:nvSpPr>
-        <p:spPr>
-          <a:xfrm>
-            <a:off x="6519672" y="2075688"/>
-            <a:ext cx="1143000" cy="182880"/>
+          <p:cNvPr id="24" name="Text 20"/>
+          <p:cNvSpPr/>
+          <p:nvPr/>
+        </p:nvSpPr>
+        <p:spPr>
+          <a:xfrm>
+            <a:off x="6528816" y="1673352"/>
+            <a:ext cx="1115568" cy="182880"/>
           </a:xfrm>
           <a:prstGeom prst="rect">
             <a:avLst/>
@@ -15070,7 +15031,7 @@
               <a:buNone/>
             </a:pPr>
             <a:r>
-              <a:rPr lang="en-US" sz="700" b="1" dirty="0">
+              <a:rPr lang="en-US" sz="750" b="1" dirty="0">
                 <a:solidFill>
                   <a:srgbClr val="1E40AF"/>
                 </a:solidFill>
@@ -15078,45 +15039,84 @@
                 <a:ea typeface="Arial" pitchFamily="34" charset="-122"/>
                 <a:cs typeface="Arial" pitchFamily="34" charset="-120"/>
               </a:rPr>
-              <a:t>85%+ LULUSAN TERSERAP</a:t>
-            </a:r>
-            <a:endParaRPr lang="en-US" sz="700" dirty="0"/>
-          </a:p>
-        </p:txBody>
-      </p:sp>
-      <p:sp>
-        <p:nvSpPr>
-          <p:cNvPr id="26" name="Text 22"/>
-          <p:cNvSpPr/>
-          <p:nvPr/>
-        </p:nvSpPr>
-        <p:spPr>
-          <a:xfrm>
-            <a:off x="4553712" y="2377440"/>
-            <a:ext cx="3090672" cy="201168"/>
-          </a:xfrm>
-          <a:prstGeom prst="rect">
-            <a:avLst/>
-          </a:prstGeom>
-          <a:noFill/>
-          <a:ln/>
-        </p:spPr>
-        <p:txBody>
-          <a:bodyPr wrap="square" rtlCol="0" anchor="ctr"/>
-          <a:lstStyle/>
-          <a:p>
-            <a:pPr indent="0" marL="0">
-              <a:buNone/>
-            </a:pPr>
-            <a:r>
-              <a:rPr lang="en-US" sz="850" b="1" dirty="0">
-                <a:solidFill>
-                  <a:srgbClr val="64748B"/>
+              <a:t>85%+ LULUS TERSERAP</a:t>
+            </a:r>
+            <a:endParaRPr lang="en-US" sz="750" dirty="0"/>
+          </a:p>
+        </p:txBody>
+      </p:sp>
+      <p:sp>
+        <p:nvSpPr>
+          <p:cNvPr id="25" name="Text 21"/>
+          <p:cNvSpPr/>
+          <p:nvPr/>
+        </p:nvSpPr>
+        <p:spPr>
+          <a:xfrm>
+            <a:off x="4553712" y="1984248"/>
+            <a:ext cx="3090672" cy="329184"/>
+          </a:xfrm>
+          <a:prstGeom prst="rect">
+            <a:avLst/>
+          </a:prstGeom>
+          <a:noFill/>
+          <a:ln/>
+        </p:spPr>
+        <p:txBody>
+          <a:bodyPr wrap="square" rtlCol="0" anchor="ctr"/>
+          <a:lstStyle/>
+          <a:p>
+            <a:pPr indent="0" marL="0">
+              <a:buNone/>
+            </a:pPr>
+            <a:r>
+              <a:rPr lang="en-US" sz="1650" b="1" dirty="0">
+                <a:solidFill>
+                  <a:srgbClr val="1E40AF"/>
                 </a:solidFill>
                 <a:latin typeface="Arial" pitchFamily="34" charset="0"/>
                 <a:ea typeface="Arial" pitchFamily="34" charset="-122"/>
                 <a:cs typeface="Arial" pitchFamily="34" charset="-120"/>
               </a:rPr>
+              <a:t>1.500 Talenta / Tahun</a:t>
+            </a:r>
+            <a:endParaRPr lang="en-US" sz="1650" dirty="0"/>
+          </a:p>
+        </p:txBody>
+      </p:sp>
+      <p:sp>
+        <p:nvSpPr>
+          <p:cNvPr id="26" name="Text 22"/>
+          <p:cNvSpPr/>
+          <p:nvPr/>
+        </p:nvSpPr>
+        <p:spPr>
+          <a:xfrm>
+            <a:off x="4553712" y="2331720"/>
+            <a:ext cx="3090672" cy="201168"/>
+          </a:xfrm>
+          <a:prstGeom prst="rect">
+            <a:avLst/>
+          </a:prstGeom>
+          <a:noFill/>
+          <a:ln/>
+        </p:spPr>
+        <p:txBody>
+          <a:bodyPr wrap="square" rtlCol="0" anchor="ctr"/>
+          <a:lstStyle/>
+          <a:p>
+            <a:pPr indent="0" marL="0">
+              <a:buNone/>
+            </a:pPr>
+            <a:r>
+              <a:rPr lang="en-US" sz="850" b="1" dirty="0">
+                <a:solidFill>
+                  <a:srgbClr val="64748B"/>
+                </a:solidFill>
+                <a:latin typeface="Arial" pitchFamily="34" charset="0"/>
+                <a:ea typeface="Arial" pitchFamily="34" charset="-122"/>
+                <a:cs typeface="Arial" pitchFamily="34" charset="-120"/>
+              </a:rPr>
               <a:t>Terserap Industri dengan Upah Layak</a:t>
             </a:r>
             <a:endParaRPr lang="en-US" sz="850" dirty="0"/>
@@ -15131,7 +15131,7 @@
         </p:nvSpPr>
         <p:spPr>
           <a:xfrm>
-            <a:off x="4553712" y="2624328"/>
+            <a:off x="4553712" y="2569464"/>
             <a:ext cx="3090672" cy="0"/>
           </a:xfrm>
           <a:prstGeom prst="line">
@@ -15154,8 +15154,8 @@
         </p:nvSpPr>
         <p:spPr>
           <a:xfrm>
-            <a:off x="4553712" y="2697480"/>
-            <a:ext cx="3090672" cy="685800"/>
+            <a:off x="4553712" y="2642616"/>
+            <a:ext cx="3090672" cy="713232"/>
           </a:xfrm>
           <a:prstGeom prst="rect">
             <a:avLst/>
@@ -15169,12 +15169,12 @@
           <a:p>
             <a:pPr indent="0" marL="0">
               <a:lnSpc>
-                <a:spcPct val="120000"/>
+                <a:spcPct val="118000"/>
               </a:lnSpc>
               <a:buNone/>
             </a:pPr>
             <a:r>
-              <a:rPr lang="en-US" sz="1000" dirty="0">
+              <a:rPr lang="en-US" sz="950" dirty="0">
                 <a:solidFill>
                   <a:srgbClr val="475569"/>
                 </a:solidFill>
@@ -15184,7 +15184,7 @@
               </a:rPr>
               <a:t>85%+ lulusan diklat vokasi STP langsung terserap di industri teknologi nasional dan manufaktur presisi, menekan angka pengangguran terbuka.</a:t>
             </a:r>
-            <a:endParaRPr lang="en-US" sz="1000" dirty="0"/>
+            <a:endParaRPr lang="en-US" sz="950" dirty="0"/>
           </a:p>
         </p:txBody>
       </p:sp>
@@ -15247,7 +15247,7 @@
         <p:spPr>
           <a:xfrm>
             <a:off x="8193024" y="1655064"/>
-            <a:ext cx="438912" cy="438912"/>
+            <a:ext cx="420624" cy="420624"/>
           </a:xfrm>
           <a:prstGeom prst="rect">
             <a:avLst/>
@@ -15286,7 +15286,7 @@
         <p:spPr>
           <a:xfrm>
             <a:off x="8266176" y="1728216"/>
-            <a:ext cx="292608" cy="292608"/>
+            <a:ext cx="274320" cy="274320"/>
           </a:xfrm>
           <a:prstGeom prst="rect">
             <a:avLst/>
@@ -15301,24 +15301,24 @@
         </p:nvSpPr>
         <p:spPr>
           <a:xfrm>
-            <a:off x="8604504" y="1655064"/>
-            <a:ext cx="2651760" cy="228600"/>
-          </a:xfrm>
-          <a:prstGeom prst="rect">
-            <a:avLst/>
-          </a:prstGeom>
-          <a:noFill/>
-          <a:ln/>
-        </p:spPr>
-        <p:txBody>
-          <a:bodyPr wrap="square" rtlCol="0" anchor="ctr"/>
-          <a:lstStyle/>
-          <a:p>
-            <a:pPr indent="0" marL="0">
-              <a:buNone/>
-            </a:pPr>
-            <a:r>
-              <a:rPr lang="en-US" sz="1000" b="1" dirty="0">
+            <a:off x="8558784" y="1655064"/>
+            <a:ext cx="1554480" cy="219456"/>
+          </a:xfrm>
+          <a:prstGeom prst="rect">
+            <a:avLst/>
+          </a:prstGeom>
+          <a:noFill/>
+          <a:ln/>
+        </p:spPr>
+        <p:txBody>
+          <a:bodyPr wrap="square" rtlCol="0" anchor="ctr"/>
+          <a:lstStyle/>
+          <a:p>
+            <a:pPr indent="0" marL="0">
+              <a:buNone/>
+            </a:pPr>
+            <a:r>
+              <a:rPr lang="en-US" sz="950" b="1" dirty="0">
                 <a:solidFill>
                   <a:srgbClr val="0F172A"/>
                 </a:solidFill>
@@ -15326,61 +15326,22 @@
                 <a:ea typeface="Arial" pitchFamily="34" charset="-122"/>
                 <a:cs typeface="Arial" pitchFamily="34" charset="-120"/>
               </a:rPr>
-              <a:t>3. FISKAL &amp; PAD DAERAH</a:t>
-            </a:r>
-            <a:endParaRPr lang="en-US" sz="1000" dirty="0"/>
-          </a:p>
-        </p:txBody>
-      </p:sp>
-      <p:sp>
-        <p:nvSpPr>
-          <p:cNvPr id="34" name="Text 29"/>
-          <p:cNvSpPr/>
-          <p:nvPr/>
-        </p:nvSpPr>
-        <p:spPr>
-          <a:xfrm>
-            <a:off x="8193024" y="2011680"/>
-            <a:ext cx="2011680" cy="347472"/>
-          </a:xfrm>
-          <a:prstGeom prst="rect">
-            <a:avLst/>
-          </a:prstGeom>
-          <a:noFill/>
-          <a:ln/>
-        </p:spPr>
-        <p:txBody>
-          <a:bodyPr wrap="square" rtlCol="0" anchor="ctr"/>
-          <a:lstStyle/>
-          <a:p>
-            <a:pPr indent="0" marL="0">
-              <a:buNone/>
-            </a:pPr>
-            <a:r>
-              <a:rPr lang="en-US" sz="1700" b="1" dirty="0">
-                <a:solidFill>
-                  <a:srgbClr val="059669"/>
-                </a:solidFill>
-                <a:latin typeface="Arial" pitchFamily="34" charset="0"/>
-                <a:ea typeface="Arial" pitchFamily="34" charset="-122"/>
-                <a:cs typeface="Arial" pitchFamily="34" charset="-120"/>
-              </a:rPr>
-              <a:t>Rp 10,2 Miliar / Thn</a:t>
-            </a:r>
-            <a:endParaRPr lang="en-US" sz="1700" dirty="0"/>
-          </a:p>
-        </p:txBody>
-      </p:sp>
-      <p:sp>
-        <p:nvSpPr>
-          <p:cNvPr id="35" name="Shape 30"/>
-          <p:cNvSpPr/>
-          <p:nvPr/>
-        </p:nvSpPr>
-        <p:spPr>
-          <a:xfrm>
-            <a:off x="10158984" y="2057400"/>
-            <a:ext cx="1143000" cy="219456"/>
+              <a:t>3. FISKAL &amp; PAD</a:t>
+            </a:r>
+            <a:endParaRPr lang="en-US" sz="950" dirty="0"/>
+          </a:p>
+        </p:txBody>
+      </p:sp>
+      <p:sp>
+        <p:nvSpPr>
+          <p:cNvPr id="34" name="Shape 29"/>
+          <p:cNvSpPr/>
+          <p:nvPr/>
+        </p:nvSpPr>
+        <p:spPr>
+          <a:xfrm>
+            <a:off x="10168128" y="1655064"/>
+            <a:ext cx="1115568" cy="219456"/>
           </a:xfrm>
           <a:prstGeom prst="rect">
             <a:avLst/>
@@ -15398,14 +15359,14 @@
       </p:sp>
       <p:sp>
         <p:nvSpPr>
-          <p:cNvPr id="36" name="Text 31"/>
-          <p:cNvSpPr/>
-          <p:nvPr/>
-        </p:nvSpPr>
-        <p:spPr>
-          <a:xfrm>
-            <a:off x="10158984" y="2075688"/>
-            <a:ext cx="1143000" cy="182880"/>
+          <p:cNvPr id="35" name="Text 30"/>
+          <p:cNvSpPr/>
+          <p:nvPr/>
+        </p:nvSpPr>
+        <p:spPr>
+          <a:xfrm>
+            <a:off x="10168128" y="1673352"/>
+            <a:ext cx="1115568" cy="182880"/>
           </a:xfrm>
           <a:prstGeom prst="rect">
             <a:avLst/>
@@ -15421,7 +15382,7 @@
               <a:buNone/>
             </a:pPr>
             <a:r>
-              <a:rPr lang="en-US" sz="700" b="1" dirty="0">
+              <a:rPr lang="en-US" sz="750" b="1" dirty="0">
                 <a:solidFill>
                   <a:srgbClr val="059669"/>
                 </a:solidFill>
@@ -15429,45 +15390,84 @@
                 <a:ea typeface="Arial" pitchFamily="34" charset="-122"/>
                 <a:cs typeface="Arial" pitchFamily="34" charset="-120"/>
               </a:rPr>
-              <a:t>NOL SUBSIDI APBD 2029</a:t>
-            </a:r>
-            <a:endParaRPr lang="en-US" sz="700" dirty="0"/>
-          </a:p>
-        </p:txBody>
-      </p:sp>
-      <p:sp>
-        <p:nvSpPr>
-          <p:cNvPr id="37" name="Text 32"/>
-          <p:cNvSpPr/>
-          <p:nvPr/>
-        </p:nvSpPr>
-        <p:spPr>
-          <a:xfrm>
-            <a:off x="8193024" y="2377440"/>
-            <a:ext cx="3090672" cy="201168"/>
-          </a:xfrm>
-          <a:prstGeom prst="rect">
-            <a:avLst/>
-          </a:prstGeom>
-          <a:noFill/>
-          <a:ln/>
-        </p:spPr>
-        <p:txBody>
-          <a:bodyPr wrap="square" rtlCol="0" anchor="ctr"/>
-          <a:lstStyle/>
-          <a:p>
-            <a:pPr indent="0" marL="0">
-              <a:buNone/>
-            </a:pPr>
-            <a:r>
-              <a:rPr lang="en-US" sz="850" b="1" dirty="0">
-                <a:solidFill>
-                  <a:srgbClr val="64748B"/>
+              <a:t>NOL SUBSIDI 2029</a:t>
+            </a:r>
+            <a:endParaRPr lang="en-US" sz="750" dirty="0"/>
+          </a:p>
+        </p:txBody>
+      </p:sp>
+      <p:sp>
+        <p:nvSpPr>
+          <p:cNvPr id="36" name="Text 31"/>
+          <p:cNvSpPr/>
+          <p:nvPr/>
+        </p:nvSpPr>
+        <p:spPr>
+          <a:xfrm>
+            <a:off x="8193024" y="1984248"/>
+            <a:ext cx="3090672" cy="329184"/>
+          </a:xfrm>
+          <a:prstGeom prst="rect">
+            <a:avLst/>
+          </a:prstGeom>
+          <a:noFill/>
+          <a:ln/>
+        </p:spPr>
+        <p:txBody>
+          <a:bodyPr wrap="square" rtlCol="0" anchor="ctr"/>
+          <a:lstStyle/>
+          <a:p>
+            <a:pPr indent="0" marL="0">
+              <a:buNone/>
+            </a:pPr>
+            <a:r>
+              <a:rPr lang="en-US" sz="1650" b="1" dirty="0">
+                <a:solidFill>
+                  <a:srgbClr val="059669"/>
                 </a:solidFill>
                 <a:latin typeface="Arial" pitchFamily="34" charset="0"/>
                 <a:ea typeface="Arial" pitchFamily="34" charset="-122"/>
                 <a:cs typeface="Arial" pitchFamily="34" charset="-120"/>
               </a:rPr>
+              <a:t>Rp 10,2 Miliar / Tahun</a:t>
+            </a:r>
+            <a:endParaRPr lang="en-US" sz="1650" dirty="0"/>
+          </a:p>
+        </p:txBody>
+      </p:sp>
+      <p:sp>
+        <p:nvSpPr>
+          <p:cNvPr id="37" name="Text 32"/>
+          <p:cNvSpPr/>
+          <p:nvPr/>
+        </p:nvSpPr>
+        <p:spPr>
+          <a:xfrm>
+            <a:off x="8193024" y="2331720"/>
+            <a:ext cx="3090672" cy="201168"/>
+          </a:xfrm>
+          <a:prstGeom prst="rect">
+            <a:avLst/>
+          </a:prstGeom>
+          <a:noFill/>
+          <a:ln/>
+        </p:spPr>
+        <p:txBody>
+          <a:bodyPr wrap="square" rtlCol="0" anchor="ctr"/>
+          <a:lstStyle/>
+          <a:p>
+            <a:pPr indent="0" marL="0">
+              <a:buNone/>
+            </a:pPr>
+            <a:r>
+              <a:rPr lang="en-US" sz="850" b="1" dirty="0">
+                <a:solidFill>
+                  <a:srgbClr val="64748B"/>
+                </a:solidFill>
+                <a:latin typeface="Arial" pitchFamily="34" charset="0"/>
+                <a:ea typeface="Arial" pitchFamily="34" charset="-122"/>
+                <a:cs typeface="Arial" pitchFamily="34" charset="-120"/>
+              </a:rPr>
               <a:t>Efisiensi Belanja APBD Pasca-BEP</a:t>
             </a:r>
             <a:endParaRPr lang="en-US" sz="850" dirty="0"/>
@@ -15482,7 +15482,7 @@
         </p:nvSpPr>
         <p:spPr>
           <a:xfrm>
-            <a:off x="8193024" y="2624328"/>
+            <a:off x="8193024" y="2569464"/>
             <a:ext cx="3090672" cy="0"/>
           </a:xfrm>
           <a:prstGeom prst="line">
@@ -15505,8 +15505,8 @@
         </p:nvSpPr>
         <p:spPr>
           <a:xfrm>
-            <a:off x="8193024" y="2697480"/>
-            <a:ext cx="3090672" cy="685800"/>
+            <a:off x="8193024" y="2642616"/>
+            <a:ext cx="3090672" cy="713232"/>
           </a:xfrm>
           <a:prstGeom prst="rect">
             <a:avLst/>
@@ -15520,12 +15520,12 @@
           <a:p>
             <a:pPr indent="0" marL="0">
               <a:lnSpc>
-                <a:spcPct val="120000"/>
+                <a:spcPct val="118000"/>
               </a:lnSpc>
               <a:buNone/>
             </a:pPr>
             <a:r>
-              <a:rPr lang="en-US" sz="1000" dirty="0">
+              <a:rPr lang="en-US" sz="950" dirty="0">
                 <a:solidFill>
                   <a:srgbClr val="475569"/>
                 </a:solidFill>
@@ -15535,7 +15535,7 @@
               </a:rPr>
               <a:t>APBD tidak lagi terbebani subsidi operasional STP; kas daerah justru menerima kontribusi PAD melalui pajak dan retribusi kegiatan komersial.</a:t>
             </a:r>
-            <a:endParaRPr lang="en-US" sz="1000" dirty="0"/>
+            <a:endParaRPr lang="en-US" sz="950" dirty="0"/>
           </a:p>
         </p:txBody>
       </p:sp>
@@ -15598,7 +15598,7 @@
         <p:spPr>
           <a:xfrm>
             <a:off x="914400" y="3712464"/>
-            <a:ext cx="438912" cy="438912"/>
+            <a:ext cx="420624" cy="420624"/>
           </a:xfrm>
           <a:prstGeom prst="rect">
             <a:avLst/>
@@ -15637,7 +15637,7 @@
         <p:spPr>
           <a:xfrm>
             <a:off x="987552" y="3785616"/>
-            <a:ext cx="292608" cy="292608"/>
+            <a:ext cx="274320" cy="274320"/>
           </a:xfrm>
           <a:prstGeom prst="rect">
             <a:avLst/>
@@ -15652,24 +15652,24 @@
         </p:nvSpPr>
         <p:spPr>
           <a:xfrm>
-            <a:off x="1325880" y="3712464"/>
-            <a:ext cx="2651760" cy="228600"/>
-          </a:xfrm>
-          <a:prstGeom prst="rect">
-            <a:avLst/>
-          </a:prstGeom>
-          <a:noFill/>
-          <a:ln/>
-        </p:spPr>
-        <p:txBody>
-          <a:bodyPr wrap="square" rtlCol="0" anchor="ctr"/>
-          <a:lstStyle/>
-          <a:p>
-            <a:pPr indent="0" marL="0">
-              <a:buNone/>
-            </a:pPr>
-            <a:r>
-              <a:rPr lang="en-US" sz="1000" b="1" dirty="0">
+            <a:off x="1280160" y="3712464"/>
+            <a:ext cx="1554480" cy="219456"/>
+          </a:xfrm>
+          <a:prstGeom prst="rect">
+            <a:avLst/>
+          </a:prstGeom>
+          <a:noFill/>
+          <a:ln/>
+        </p:spPr>
+        <p:txBody>
+          <a:bodyPr wrap="square" rtlCol="0" anchor="ctr"/>
+          <a:lstStyle/>
+          <a:p>
+            <a:pPr indent="0" marL="0">
+              <a:buNone/>
+            </a:pPr>
+            <a:r>
+              <a:rPr lang="en-US" sz="950" b="1" dirty="0">
                 <a:solidFill>
                   <a:srgbClr val="0F172A"/>
                 </a:solidFill>
@@ -15677,61 +15677,22 @@
                 <a:ea typeface="Arial" pitchFamily="34" charset="-122"/>
                 <a:cs typeface="Arial" pitchFamily="34" charset="-120"/>
               </a:rPr>
-              <a:t>4. EKOSISTEM INOVASI &amp; HKI</a:t>
-            </a:r>
-            <a:endParaRPr lang="en-US" sz="1000" dirty="0"/>
-          </a:p>
-        </p:txBody>
-      </p:sp>
-      <p:sp>
-        <p:nvSpPr>
-          <p:cNvPr id="45" name="Text 39"/>
-          <p:cNvSpPr/>
-          <p:nvPr/>
-        </p:nvSpPr>
-        <p:spPr>
-          <a:xfrm>
-            <a:off x="914400" y="4069080"/>
-            <a:ext cx="2011680" cy="347472"/>
-          </a:xfrm>
-          <a:prstGeom prst="rect">
-            <a:avLst/>
-          </a:prstGeom>
-          <a:noFill/>
-          <a:ln/>
-        </p:spPr>
-        <p:txBody>
-          <a:bodyPr wrap="square" rtlCol="0" anchor="ctr"/>
-          <a:lstStyle/>
-          <a:p>
-            <a:pPr indent="0" marL="0">
-              <a:buNone/>
-            </a:pPr>
-            <a:r>
-              <a:rPr lang="en-US" sz="1700" b="1" dirty="0">
-                <a:solidFill>
-                  <a:srgbClr val="D97706"/>
-                </a:solidFill>
-                <a:latin typeface="Arial" pitchFamily="34" charset="0"/>
-                <a:ea typeface="Arial" pitchFamily="34" charset="-122"/>
-                <a:cs typeface="Arial" pitchFamily="34" charset="-120"/>
-              </a:rPr>
-              <a:t>50+ Paten &amp; Cipta</a:t>
-            </a:r>
-            <a:endParaRPr lang="en-US" sz="1700" dirty="0"/>
-          </a:p>
-        </p:txBody>
-      </p:sp>
-      <p:sp>
-        <p:nvSpPr>
-          <p:cNvPr id="46" name="Shape 40"/>
-          <p:cNvSpPr/>
-          <p:nvPr/>
-        </p:nvSpPr>
-        <p:spPr>
-          <a:xfrm>
-            <a:off x="2880360" y="4114800"/>
-            <a:ext cx="1143000" cy="219456"/>
+              <a:t>4. EKOSISTEM HKI</a:t>
+            </a:r>
+            <a:endParaRPr lang="en-US" sz="950" dirty="0"/>
+          </a:p>
+        </p:txBody>
+      </p:sp>
+      <p:sp>
+        <p:nvSpPr>
+          <p:cNvPr id="45" name="Shape 39"/>
+          <p:cNvSpPr/>
+          <p:nvPr/>
+        </p:nvSpPr>
+        <p:spPr>
+          <a:xfrm>
+            <a:off x="2889504" y="3712464"/>
+            <a:ext cx="1115568" cy="219456"/>
           </a:xfrm>
           <a:prstGeom prst="rect">
             <a:avLst/>
@@ -15749,14 +15710,14 @@
       </p:sp>
       <p:sp>
         <p:nvSpPr>
-          <p:cNvPr id="47" name="Text 41"/>
-          <p:cNvSpPr/>
-          <p:nvPr/>
-        </p:nvSpPr>
-        <p:spPr>
-          <a:xfrm>
-            <a:off x="2880360" y="4133088"/>
-            <a:ext cx="1143000" cy="182880"/>
+          <p:cNvPr id="46" name="Text 40"/>
+          <p:cNvSpPr/>
+          <p:nvPr/>
+        </p:nvSpPr>
+        <p:spPr>
+          <a:xfrm>
+            <a:off x="2889504" y="3730752"/>
+            <a:ext cx="1115568" cy="182880"/>
           </a:xfrm>
           <a:prstGeom prst="rect">
             <a:avLst/>
@@ -15772,7 +15733,7 @@
               <a:buNone/>
             </a:pPr>
             <a:r>
-              <a:rPr lang="en-US" sz="700" b="1" dirty="0">
+              <a:rPr lang="en-US" sz="750" b="1" dirty="0">
                 <a:solidFill>
                   <a:srgbClr val="D97706"/>
                 </a:solidFill>
@@ -15780,45 +15741,84 @@
                 <a:ea typeface="Arial" pitchFamily="34" charset="-122"/>
                 <a:cs typeface="Arial" pitchFamily="34" charset="-120"/>
               </a:rPr>
-              <a:t>RUJUKAN INOVASI JATENG</a:t>
-            </a:r>
-            <a:endParaRPr lang="en-US" sz="700" dirty="0"/>
-          </a:p>
-        </p:txBody>
-      </p:sp>
-      <p:sp>
-        <p:nvSpPr>
-          <p:cNvPr id="48" name="Text 42"/>
-          <p:cNvSpPr/>
-          <p:nvPr/>
-        </p:nvSpPr>
-        <p:spPr>
-          <a:xfrm>
-            <a:off x="914400" y="4434840"/>
-            <a:ext cx="3090672" cy="201168"/>
-          </a:xfrm>
-          <a:prstGeom prst="rect">
-            <a:avLst/>
-          </a:prstGeom>
-          <a:noFill/>
-          <a:ln/>
-        </p:spPr>
-        <p:txBody>
-          <a:bodyPr wrap="square" rtlCol="0" anchor="ctr"/>
-          <a:lstStyle/>
-          <a:p>
-            <a:pPr indent="0" marL="0">
-              <a:buNone/>
-            </a:pPr>
-            <a:r>
-              <a:rPr lang="en-US" sz="850" b="1" dirty="0">
-                <a:solidFill>
-                  <a:srgbClr val="64748B"/>
+              <a:t>RUJUKAN INOVASI</a:t>
+            </a:r>
+            <a:endParaRPr lang="en-US" sz="750" dirty="0"/>
+          </a:p>
+        </p:txBody>
+      </p:sp>
+      <p:sp>
+        <p:nvSpPr>
+          <p:cNvPr id="47" name="Text 41"/>
+          <p:cNvSpPr/>
+          <p:nvPr/>
+        </p:nvSpPr>
+        <p:spPr>
+          <a:xfrm>
+            <a:off x="914400" y="4041648"/>
+            <a:ext cx="3090672" cy="329184"/>
+          </a:xfrm>
+          <a:prstGeom prst="rect">
+            <a:avLst/>
+          </a:prstGeom>
+          <a:noFill/>
+          <a:ln/>
+        </p:spPr>
+        <p:txBody>
+          <a:bodyPr wrap="square" rtlCol="0" anchor="ctr"/>
+          <a:lstStyle/>
+          <a:p>
+            <a:pPr indent="0" marL="0">
+              <a:buNone/>
+            </a:pPr>
+            <a:r>
+              <a:rPr lang="en-US" sz="1650" b="1" dirty="0">
+                <a:solidFill>
+                  <a:srgbClr val="D97706"/>
                 </a:solidFill>
                 <a:latin typeface="Arial" pitchFamily="34" charset="0"/>
                 <a:ea typeface="Arial" pitchFamily="34" charset="-122"/>
                 <a:cs typeface="Arial" pitchFamily="34" charset="-120"/>
               </a:rPr>
+              <a:t>50+ Paten &amp; Hak Cipta</a:t>
+            </a:r>
+            <a:endParaRPr lang="en-US" sz="1650" dirty="0"/>
+          </a:p>
+        </p:txBody>
+      </p:sp>
+      <p:sp>
+        <p:nvSpPr>
+          <p:cNvPr id="48" name="Text 42"/>
+          <p:cNvSpPr/>
+          <p:nvPr/>
+        </p:nvSpPr>
+        <p:spPr>
+          <a:xfrm>
+            <a:off x="914400" y="4389120"/>
+            <a:ext cx="3090672" cy="201168"/>
+          </a:xfrm>
+          <a:prstGeom prst="rect">
+            <a:avLst/>
+          </a:prstGeom>
+          <a:noFill/>
+          <a:ln/>
+        </p:spPr>
+        <p:txBody>
+          <a:bodyPr wrap="square" rtlCol="0" anchor="ctr"/>
+          <a:lstStyle/>
+          <a:p>
+            <a:pPr indent="0" marL="0">
+              <a:buNone/>
+            </a:pPr>
+            <a:r>
+              <a:rPr lang="en-US" sz="850" b="1" dirty="0">
+                <a:solidFill>
+                  <a:srgbClr val="64748B"/>
+                </a:solidFill>
+                <a:latin typeface="Arial" pitchFamily="34" charset="0"/>
+                <a:ea typeface="Arial" pitchFamily="34" charset="-122"/>
+                <a:cs typeface="Arial" pitchFamily="34" charset="-120"/>
+              </a:rPr>
               <a:t>Didaftarkan &amp; Dilisensikan ke Industri</a:t>
             </a:r>
             <a:endParaRPr lang="en-US" sz="850" dirty="0"/>
@@ -15833,7 +15833,7 @@
         </p:nvSpPr>
         <p:spPr>
           <a:xfrm>
-            <a:off x="914400" y="4681728"/>
+            <a:off x="914400" y="4626864"/>
             <a:ext cx="3090672" cy="0"/>
           </a:xfrm>
           <a:prstGeom prst="line">
@@ -15856,8 +15856,8 @@
         </p:nvSpPr>
         <p:spPr>
           <a:xfrm>
-            <a:off x="914400" y="4754880"/>
-            <a:ext cx="3090672" cy="685800"/>
+            <a:off x="914400" y="4700016"/>
+            <a:ext cx="3090672" cy="713232"/>
           </a:xfrm>
           <a:prstGeom prst="rect">
             <a:avLst/>
@@ -15871,12 +15871,12 @@
           <a:p>
             <a:pPr indent="0" marL="0">
               <a:lnSpc>
-                <a:spcPct val="120000"/>
+                <a:spcPct val="118000"/>
               </a:lnSpc>
               <a:buNone/>
             </a:pPr>
             <a:r>
-              <a:rPr lang="en-US" sz="1000" dirty="0">
+              <a:rPr lang="en-US" sz="950" dirty="0">
                 <a:solidFill>
                   <a:srgbClr val="475569"/>
                 </a:solidFill>
@@ -15886,7 +15886,7 @@
               </a:rPr>
               <a:t>Solo menjadi rujukan pendaftaran dan komersialisasi kekayaan intelektual (HKI) perguruan tinggi dan inovator lokal di Jawa Tengah.</a:t>
             </a:r>
-            <a:endParaRPr lang="en-US" sz="1000" dirty="0"/>
+            <a:endParaRPr lang="en-US" sz="950" dirty="0"/>
           </a:p>
         </p:txBody>
       </p:sp>
@@ -15949,7 +15949,7 @@
         <p:spPr>
           <a:xfrm>
             <a:off x="4553712" y="3712464"/>
-            <a:ext cx="438912" cy="438912"/>
+            <a:ext cx="420624" cy="420624"/>
           </a:xfrm>
           <a:prstGeom prst="rect">
             <a:avLst/>
@@ -15988,7 +15988,7 @@
         <p:spPr>
           <a:xfrm>
             <a:off x="4626864" y="3785616"/>
-            <a:ext cx="292608" cy="292608"/>
+            <a:ext cx="274320" cy="274320"/>
           </a:xfrm>
           <a:prstGeom prst="rect">
             <a:avLst/>
@@ -16003,24 +16003,24 @@
         </p:nvSpPr>
         <p:spPr>
           <a:xfrm>
-            <a:off x="4965192" y="3712464"/>
-            <a:ext cx="2651760" cy="228600"/>
-          </a:xfrm>
-          <a:prstGeom prst="rect">
-            <a:avLst/>
-          </a:prstGeom>
-          <a:noFill/>
-          <a:ln/>
-        </p:spPr>
-        <p:txBody>
-          <a:bodyPr wrap="square" rtlCol="0" anchor="ctr"/>
-          <a:lstStyle/>
-          <a:p>
-            <a:pPr indent="0" marL="0">
-              <a:buNone/>
-            </a:pPr>
-            <a:r>
-              <a:rPr lang="en-US" sz="1000" b="1" dirty="0">
+            <a:off x="4919472" y="3712464"/>
+            <a:ext cx="1554480" cy="219456"/>
+          </a:xfrm>
+          <a:prstGeom prst="rect">
+            <a:avLst/>
+          </a:prstGeom>
+          <a:noFill/>
+          <a:ln/>
+        </p:spPr>
+        <p:txBody>
+          <a:bodyPr wrap="square" rtlCol="0" anchor="ctr"/>
+          <a:lstStyle/>
+          <a:p>
+            <a:pPr indent="0" marL="0">
+              <a:buNone/>
+            </a:pPr>
+            <a:r>
+              <a:rPr lang="en-US" sz="950" b="1" dirty="0">
                 <a:solidFill>
                   <a:srgbClr val="0F172A"/>
                 </a:solidFill>
@@ -16028,61 +16028,22 @@
                 <a:ea typeface="Arial" pitchFamily="34" charset="-122"/>
                 <a:cs typeface="Arial" pitchFamily="34" charset="-120"/>
               </a:rPr>
-              <a:t>5. BRANDING KOTA INOVATIF</a:t>
-            </a:r>
-            <a:endParaRPr lang="en-US" sz="1000" dirty="0"/>
-          </a:p>
-        </p:txBody>
-      </p:sp>
-      <p:sp>
-        <p:nvSpPr>
-          <p:cNvPr id="56" name="Text 49"/>
-          <p:cNvSpPr/>
-          <p:nvPr/>
-        </p:nvSpPr>
-        <p:spPr>
-          <a:xfrm>
-            <a:off x="4553712" y="4069080"/>
-            <a:ext cx="2011680" cy="347472"/>
-          </a:xfrm>
-          <a:prstGeom prst="rect">
-            <a:avLst/>
-          </a:prstGeom>
-          <a:noFill/>
-          <a:ln/>
-        </p:spPr>
-        <p:txBody>
-          <a:bodyPr wrap="square" rtlCol="0" anchor="ctr"/>
-          <a:lstStyle/>
-          <a:p>
-            <a:pPr indent="0" marL="0">
-              <a:buNone/>
-            </a:pPr>
-            <a:r>
-              <a:rPr lang="en-US" sz="1700" b="1" dirty="0">
-                <a:solidFill>
-                  <a:srgbClr val="7C3AED"/>
-                </a:solidFill>
-                <a:latin typeface="Arial" pitchFamily="34" charset="0"/>
-                <a:ea typeface="Arial" pitchFamily="34" charset="-122"/>
-                <a:cs typeface="Arial" pitchFamily="34" charset="-120"/>
-              </a:rPr>
-              <a:t>Top-3 KST Nasional</a:t>
-            </a:r>
-            <a:endParaRPr lang="en-US" sz="1700" dirty="0"/>
-          </a:p>
-        </p:txBody>
-      </p:sp>
-      <p:sp>
-        <p:nvSpPr>
-          <p:cNvPr id="57" name="Shape 50"/>
-          <p:cNvSpPr/>
-          <p:nvPr/>
-        </p:nvSpPr>
-        <p:spPr>
-          <a:xfrm>
-            <a:off x="6519672" y="4114800"/>
-            <a:ext cx="1143000" cy="219456"/>
+              <a:t>5. BRANDING KOTA</a:t>
+            </a:r>
+            <a:endParaRPr lang="en-US" sz="950" dirty="0"/>
+          </a:p>
+        </p:txBody>
+      </p:sp>
+      <p:sp>
+        <p:nvSpPr>
+          <p:cNvPr id="56" name="Shape 49"/>
+          <p:cNvSpPr/>
+          <p:nvPr/>
+        </p:nvSpPr>
+        <p:spPr>
+          <a:xfrm>
+            <a:off x="6528816" y="3712464"/>
+            <a:ext cx="1115568" cy="219456"/>
           </a:xfrm>
           <a:prstGeom prst="rect">
             <a:avLst/>
@@ -16100,14 +16061,14 @@
       </p:sp>
       <p:sp>
         <p:nvSpPr>
-          <p:cNvPr id="58" name="Text 51"/>
-          <p:cNvSpPr/>
-          <p:nvPr/>
-        </p:nvSpPr>
-        <p:spPr>
-          <a:xfrm>
-            <a:off x="6519672" y="4133088"/>
-            <a:ext cx="1143000" cy="182880"/>
+          <p:cNvPr id="57" name="Text 50"/>
+          <p:cNvSpPr/>
+          <p:nvPr/>
+        </p:nvSpPr>
+        <p:spPr>
+          <a:xfrm>
+            <a:off x="6528816" y="3730752"/>
+            <a:ext cx="1115568" cy="182880"/>
           </a:xfrm>
           <a:prstGeom prst="rect">
             <a:avLst/>
@@ -16123,7 +16084,7 @@
               <a:buNone/>
             </a:pPr>
             <a:r>
-              <a:rPr lang="en-US" sz="700" b="1" dirty="0">
+              <a:rPr lang="en-US" sz="750" b="1" dirty="0">
                 <a:solidFill>
                   <a:srgbClr val="7C3AED"/>
                 </a:solidFill>
@@ -16131,45 +16092,84 @@
                 <a:ea typeface="Arial" pitchFamily="34" charset="-122"/>
                 <a:cs typeface="Arial" pitchFamily="34" charset="-120"/>
               </a:rPr>
-              <a:t>STANDAR INTERNASIONAL</a:t>
-            </a:r>
-            <a:endParaRPr lang="en-US" sz="700" dirty="0"/>
-          </a:p>
-        </p:txBody>
-      </p:sp>
-      <p:sp>
-        <p:nvSpPr>
-          <p:cNvPr id="59" name="Text 52"/>
-          <p:cNvSpPr/>
-          <p:nvPr/>
-        </p:nvSpPr>
-        <p:spPr>
-          <a:xfrm>
-            <a:off x="4553712" y="4434840"/>
-            <a:ext cx="3090672" cy="201168"/>
-          </a:xfrm>
-          <a:prstGeom prst="rect">
-            <a:avLst/>
-          </a:prstGeom>
-          <a:noFill/>
-          <a:ln/>
-        </p:spPr>
-        <p:txBody>
-          <a:bodyPr wrap="square" rtlCol="0" anchor="ctr"/>
-          <a:lstStyle/>
-          <a:p>
-            <a:pPr indent="0" marL="0">
-              <a:buNone/>
-            </a:pPr>
-            <a:r>
-              <a:rPr lang="en-US" sz="850" b="1" dirty="0">
-                <a:solidFill>
-                  <a:srgbClr val="64748B"/>
+              <a:t>STANDAR GLOBAL</a:t>
+            </a:r>
+            <a:endParaRPr lang="en-US" sz="750" dirty="0"/>
+          </a:p>
+        </p:txBody>
+      </p:sp>
+      <p:sp>
+        <p:nvSpPr>
+          <p:cNvPr id="58" name="Text 51"/>
+          <p:cNvSpPr/>
+          <p:nvPr/>
+        </p:nvSpPr>
+        <p:spPr>
+          <a:xfrm>
+            <a:off x="4553712" y="4041648"/>
+            <a:ext cx="3090672" cy="329184"/>
+          </a:xfrm>
+          <a:prstGeom prst="rect">
+            <a:avLst/>
+          </a:prstGeom>
+          <a:noFill/>
+          <a:ln/>
+        </p:spPr>
+        <p:txBody>
+          <a:bodyPr wrap="square" rtlCol="0" anchor="ctr"/>
+          <a:lstStyle/>
+          <a:p>
+            <a:pPr indent="0" marL="0">
+              <a:buNone/>
+            </a:pPr>
+            <a:r>
+              <a:rPr lang="en-US" sz="1650" b="1" dirty="0">
+                <a:solidFill>
+                  <a:srgbClr val="7C3AED"/>
                 </a:solidFill>
                 <a:latin typeface="Arial" pitchFamily="34" charset="0"/>
                 <a:ea typeface="Arial" pitchFamily="34" charset="-122"/>
                 <a:cs typeface="Arial" pitchFamily="34" charset="-120"/>
               </a:rPr>
+              <a:t>Top-3 KST Nasional</a:t>
+            </a:r>
+            <a:endParaRPr lang="en-US" sz="1650" dirty="0"/>
+          </a:p>
+        </p:txBody>
+      </p:sp>
+      <p:sp>
+        <p:nvSpPr>
+          <p:cNvPr id="59" name="Text 52"/>
+          <p:cNvSpPr/>
+          <p:nvPr/>
+        </p:nvSpPr>
+        <p:spPr>
+          <a:xfrm>
+            <a:off x="4553712" y="4389120"/>
+            <a:ext cx="3090672" cy="201168"/>
+          </a:xfrm>
+          <a:prstGeom prst="rect">
+            <a:avLst/>
+          </a:prstGeom>
+          <a:noFill/>
+          <a:ln/>
+        </p:spPr>
+        <p:txBody>
+          <a:bodyPr wrap="square" rtlCol="0" anchor="ctr"/>
+          <a:lstStyle/>
+          <a:p>
+            <a:pPr indent="0" marL="0">
+              <a:buNone/>
+            </a:pPr>
+            <a:r>
+              <a:rPr lang="en-US" sz="850" b="1" dirty="0">
+                <a:solidFill>
+                  <a:srgbClr val="64748B"/>
+                </a:solidFill>
+                <a:latin typeface="Arial" pitchFamily="34" charset="0"/>
+                <a:ea typeface="Arial" pitchFamily="34" charset="-122"/>
+                <a:cs typeface="Arial" pitchFamily="34" charset="-120"/>
+              </a:rPr>
               <a:t>Rujukan Nasional &amp; Internasional</a:t>
             </a:r>
             <a:endParaRPr lang="en-US" sz="850" dirty="0"/>
@@ -16184,7 +16184,7 @@
         </p:nvSpPr>
         <p:spPr>
           <a:xfrm>
-            <a:off x="4553712" y="4681728"/>
+            <a:off x="4553712" y="4626864"/>
             <a:ext cx="3090672" cy="0"/>
           </a:xfrm>
           <a:prstGeom prst="line">
@@ -16207,8 +16207,8 @@
         </p:nvSpPr>
         <p:spPr>
           <a:xfrm>
-            <a:off x="4553712" y="4754880"/>
-            <a:ext cx="3090672" cy="685800"/>
+            <a:off x="4553712" y="4700016"/>
+            <a:ext cx="3090672" cy="713232"/>
           </a:xfrm>
           <a:prstGeom prst="rect">
             <a:avLst/>
@@ -16222,12 +16222,12 @@
           <a:p>
             <a:pPr indent="0" marL="0">
               <a:lnSpc>
-                <a:spcPct val="120000"/>
+                <a:spcPct val="118000"/>
               </a:lnSpc>
               <a:buNone/>
             </a:pPr>
             <a:r>
-              <a:rPr lang="en-US" sz="1000" dirty="0">
+              <a:rPr lang="en-US" sz="950" dirty="0">
                 <a:solidFill>
                   <a:srgbClr val="475569"/>
                 </a:solidFill>
@@ -16237,7 +16237,7 @@
               </a:rPr>
               <a:t>Meningkatkan citra Kota Surakarta dari kota budaya-heritage menjadi kota modern yang memadukan budaya luhur dengan inovasi teknologi masa depan.</a:t>
             </a:r>
-            <a:endParaRPr lang="en-US" sz="1000" dirty="0"/>
+            <a:endParaRPr lang="en-US" sz="950" dirty="0"/>
           </a:p>
         </p:txBody>
       </p:sp>
@@ -16300,7 +16300,7 @@
         <p:spPr>
           <a:xfrm>
             <a:off x="8193024" y="3712464"/>
-            <a:ext cx="438912" cy="438912"/>
+            <a:ext cx="420624" cy="420624"/>
           </a:xfrm>
           <a:prstGeom prst="rect">
             <a:avLst/>
@@ -16339,7 +16339,7 @@
         <p:spPr>
           <a:xfrm>
             <a:off x="8266176" y="3785616"/>
-            <a:ext cx="292608" cy="292608"/>
+            <a:ext cx="274320" cy="274320"/>
           </a:xfrm>
           <a:prstGeom prst="rect">
             <a:avLst/>
@@ -16354,24 +16354,24 @@
         </p:nvSpPr>
         <p:spPr>
           <a:xfrm>
-            <a:off x="8604504" y="3712464"/>
-            <a:ext cx="2651760" cy="228600"/>
-          </a:xfrm>
-          <a:prstGeom prst="rect">
-            <a:avLst/>
-          </a:prstGeom>
-          <a:noFill/>
-          <a:ln/>
-        </p:spPr>
-        <p:txBody>
-          <a:bodyPr wrap="square" rtlCol="0" anchor="ctr"/>
-          <a:lstStyle/>
-          <a:p>
-            <a:pPr indent="0" marL="0">
-              <a:buNone/>
-            </a:pPr>
-            <a:r>
-              <a:rPr lang="en-US" sz="1000" b="1" dirty="0">
+            <a:off x="8558784" y="3712464"/>
+            <a:ext cx="1554480" cy="219456"/>
+          </a:xfrm>
+          <a:prstGeom prst="rect">
+            <a:avLst/>
+          </a:prstGeom>
+          <a:noFill/>
+          <a:ln/>
+        </p:spPr>
+        <p:txBody>
+          <a:bodyPr wrap="square" rtlCol="0" anchor="ctr"/>
+          <a:lstStyle/>
+          <a:p>
+            <a:pPr indent="0" marL="0">
+              <a:buNone/>
+            </a:pPr>
+            <a:r>
+              <a:rPr lang="en-US" sz="950" b="1" dirty="0">
                 <a:solidFill>
                   <a:srgbClr val="0F172A"/>
                 </a:solidFill>
@@ -16379,61 +16379,22 @@
                 <a:ea typeface="Arial" pitchFamily="34" charset="-122"/>
                 <a:cs typeface="Arial" pitchFamily="34" charset="-120"/>
               </a:rPr>
-              <a:t>6. INKLUSI &amp; EDUKASI WARGA</a:t>
-            </a:r>
-            <a:endParaRPr lang="en-US" sz="1000" dirty="0"/>
-          </a:p>
-        </p:txBody>
-      </p:sp>
-      <p:sp>
-        <p:nvSpPr>
-          <p:cNvPr id="67" name="Text 59"/>
-          <p:cNvSpPr/>
-          <p:nvPr/>
-        </p:nvSpPr>
-        <p:spPr>
-          <a:xfrm>
-            <a:off x="8193024" y="4069080"/>
-            <a:ext cx="2011680" cy="347472"/>
-          </a:xfrm>
-          <a:prstGeom prst="rect">
-            <a:avLst/>
-          </a:prstGeom>
-          <a:noFill/>
-          <a:ln/>
-        </p:spPr>
-        <p:txBody>
-          <a:bodyPr wrap="square" rtlCol="0" anchor="ctr"/>
-          <a:lstStyle/>
-          <a:p>
-            <a:pPr indent="0" marL="0">
-              <a:buNone/>
-            </a:pPr>
-            <a:r>
-              <a:rPr lang="en-US" sz="1700" b="1" dirty="0">
-                <a:solidFill>
-                  <a:srgbClr val="DC2626"/>
-                </a:solidFill>
-                <a:latin typeface="Arial" pitchFamily="34" charset="0"/>
-                <a:ea typeface="Arial" pitchFamily="34" charset="-122"/>
-                <a:cs typeface="Arial" pitchFamily="34" charset="-120"/>
-              </a:rPr>
-              <a:t>25.000 Pelajar / Thn</a:t>
-            </a:r>
-            <a:endParaRPr lang="en-US" sz="1700" dirty="0"/>
-          </a:p>
-        </p:txBody>
-      </p:sp>
-      <p:sp>
-        <p:nvSpPr>
-          <p:cNvPr id="68" name="Shape 60"/>
-          <p:cNvSpPr/>
-          <p:nvPr/>
-        </p:nvSpPr>
-        <p:spPr>
-          <a:xfrm>
-            <a:off x="10158984" y="4114800"/>
-            <a:ext cx="1143000" cy="219456"/>
+              <a:t>6. INKLUSI WARGA</a:t>
+            </a:r>
+            <a:endParaRPr lang="en-US" sz="950" dirty="0"/>
+          </a:p>
+        </p:txBody>
+      </p:sp>
+      <p:sp>
+        <p:nvSpPr>
+          <p:cNvPr id="67" name="Shape 59"/>
+          <p:cNvSpPr/>
+          <p:nvPr/>
+        </p:nvSpPr>
+        <p:spPr>
+          <a:xfrm>
+            <a:off x="10168128" y="3712464"/>
+            <a:ext cx="1115568" cy="219456"/>
           </a:xfrm>
           <a:prstGeom prst="rect">
             <a:avLst/>
@@ -16451,14 +16412,14 @@
       </p:sp>
       <p:sp>
         <p:nvSpPr>
-          <p:cNvPr id="69" name="Text 61"/>
-          <p:cNvSpPr/>
-          <p:nvPr/>
-        </p:nvSpPr>
-        <p:spPr>
-          <a:xfrm>
-            <a:off x="10158984" y="4133088"/>
-            <a:ext cx="1143000" cy="182880"/>
+          <p:cNvPr id="68" name="Text 60"/>
+          <p:cNvSpPr/>
+          <p:nvPr/>
+        </p:nvSpPr>
+        <p:spPr>
+          <a:xfrm>
+            <a:off x="10168128" y="3730752"/>
+            <a:ext cx="1115568" cy="182880"/>
           </a:xfrm>
           <a:prstGeom prst="rect">
             <a:avLst/>
@@ -16474,7 +16435,7 @@
               <a:buNone/>
             </a:pPr>
             <a:r>
-              <a:rPr lang="en-US" sz="700" b="1" dirty="0">
+              <a:rPr lang="en-US" sz="750" b="1" dirty="0">
                 <a:solidFill>
                   <a:srgbClr val="DC2626"/>
                 </a:solidFill>
@@ -16482,45 +16443,84 @@
                 <a:ea typeface="Arial" pitchFamily="34" charset="-122"/>
                 <a:cs typeface="Arial" pitchFamily="34" charset="-120"/>
               </a:rPr>
-              <a:t>AKSES LITERASI GRATIS</a:t>
-            </a:r>
-            <a:endParaRPr lang="en-US" sz="700" dirty="0"/>
-          </a:p>
-        </p:txBody>
-      </p:sp>
-      <p:sp>
-        <p:nvSpPr>
-          <p:cNvPr id="70" name="Text 62"/>
-          <p:cNvSpPr/>
-          <p:nvPr/>
-        </p:nvSpPr>
-        <p:spPr>
-          <a:xfrm>
-            <a:off x="8193024" y="4434840"/>
-            <a:ext cx="3090672" cy="201168"/>
-          </a:xfrm>
-          <a:prstGeom prst="rect">
-            <a:avLst/>
-          </a:prstGeom>
-          <a:noFill/>
-          <a:ln/>
-        </p:spPr>
-        <p:txBody>
-          <a:bodyPr wrap="square" rtlCol="0" anchor="ctr"/>
-          <a:lstStyle/>
-          <a:p>
-            <a:pPr indent="0" marL="0">
-              <a:buNone/>
-            </a:pPr>
-            <a:r>
-              <a:rPr lang="en-US" sz="850" b="1" dirty="0">
-                <a:solidFill>
-                  <a:srgbClr val="64748B"/>
+              <a:t>LITERASI GRATIS</a:t>
+            </a:r>
+            <a:endParaRPr lang="en-US" sz="750" dirty="0"/>
+          </a:p>
+        </p:txBody>
+      </p:sp>
+      <p:sp>
+        <p:nvSpPr>
+          <p:cNvPr id="69" name="Text 61"/>
+          <p:cNvSpPr/>
+          <p:nvPr/>
+        </p:nvSpPr>
+        <p:spPr>
+          <a:xfrm>
+            <a:off x="8193024" y="4041648"/>
+            <a:ext cx="3090672" cy="329184"/>
+          </a:xfrm>
+          <a:prstGeom prst="rect">
+            <a:avLst/>
+          </a:prstGeom>
+          <a:noFill/>
+          <a:ln/>
+        </p:spPr>
+        <p:txBody>
+          <a:bodyPr wrap="square" rtlCol="0" anchor="ctr"/>
+          <a:lstStyle/>
+          <a:p>
+            <a:pPr indent="0" marL="0">
+              <a:buNone/>
+            </a:pPr>
+            <a:r>
+              <a:rPr lang="en-US" sz="1650" b="1" dirty="0">
+                <a:solidFill>
+                  <a:srgbClr val="DC2626"/>
                 </a:solidFill>
                 <a:latin typeface="Arial" pitchFamily="34" charset="0"/>
                 <a:ea typeface="Arial" pitchFamily="34" charset="-122"/>
                 <a:cs typeface="Arial" pitchFamily="34" charset="-120"/>
               </a:rPr>
+              <a:t>25.000 Pelajar / Tahun</a:t>
+            </a:r>
+            <a:endParaRPr lang="en-US" sz="1650" dirty="0"/>
+          </a:p>
+        </p:txBody>
+      </p:sp>
+      <p:sp>
+        <p:nvSpPr>
+          <p:cNvPr id="70" name="Text 62"/>
+          <p:cNvSpPr/>
+          <p:nvPr/>
+        </p:nvSpPr>
+        <p:spPr>
+          <a:xfrm>
+            <a:off x="8193024" y="4389120"/>
+            <a:ext cx="3090672" cy="201168"/>
+          </a:xfrm>
+          <a:prstGeom prst="rect">
+            <a:avLst/>
+          </a:prstGeom>
+          <a:noFill/>
+          <a:ln/>
+        </p:spPr>
+        <p:txBody>
+          <a:bodyPr wrap="square" rtlCol="0" anchor="ctr"/>
+          <a:lstStyle/>
+          <a:p>
+            <a:pPr indent="0" marL="0">
+              <a:buNone/>
+            </a:pPr>
+            <a:r>
+              <a:rPr lang="en-US" sz="850" b="1" dirty="0">
+                <a:solidFill>
+                  <a:srgbClr val="64748B"/>
+                </a:solidFill>
+                <a:latin typeface="Arial" pitchFamily="34" charset="0"/>
+                <a:ea typeface="Arial" pitchFamily="34" charset="-122"/>
+                <a:cs typeface="Arial" pitchFamily="34" charset="-120"/>
+              </a:rPr>
               <a:t>Penerima Manfaat Edukasi Sains</a:t>
             </a:r>
             <a:endParaRPr lang="en-US" sz="850" dirty="0"/>
@@ -16535,7 +16535,7 @@
         </p:nvSpPr>
         <p:spPr>
           <a:xfrm>
-            <a:off x="8193024" y="4681728"/>
+            <a:off x="8193024" y="4626864"/>
             <a:ext cx="3090672" cy="0"/>
           </a:xfrm>
           <a:prstGeom prst="line">
@@ -16558,8 +16558,8 @@
         </p:nvSpPr>
         <p:spPr>
           <a:xfrm>
-            <a:off x="8193024" y="4754880"/>
-            <a:ext cx="3090672" cy="685800"/>
+            <a:off x="8193024" y="4700016"/>
+            <a:ext cx="3090672" cy="713232"/>
           </a:xfrm>
           <a:prstGeom prst="rect">
             <a:avLst/>
@@ -16573,12 +16573,12 @@
           <a:p>
             <a:pPr indent="0" marL="0">
               <a:lnSpc>
-                <a:spcPct val="120000"/>
+                <a:spcPct val="118000"/>
               </a:lnSpc>
               <a:buNone/>
             </a:pPr>
             <a:r>
-              <a:rPr lang="en-US" sz="1000" dirty="0">
+              <a:rPr lang="en-US" sz="950" dirty="0">
                 <a:solidFill>
                   <a:srgbClr val="475569"/>
                 </a:solidFill>
@@ -16588,7 +16588,7 @@
               </a:rPr>
               <a:t>Membuka akses gratis literasi digital, kunjungan laboratorium sains, dan pelatihan coding dasar bagi anak-anak keluarga kurang mampu di Surakarta.</a:t>
             </a:r>
-            <a:endParaRPr lang="en-US" sz="1000" dirty="0"/>
+            <a:endParaRPr lang="en-US" sz="950" dirty="0"/>
           </a:p>
         </p:txBody>
       </p:sp>
@@ -16793,8 +16793,8 @@
         </p:nvSpPr>
         <p:spPr>
           <a:xfrm>
-            <a:off x="731520" y="384048"/>
-            <a:ext cx="9144000" cy="219456"/>
+            <a:off x="731520" y="329184"/>
+            <a:ext cx="9144000" cy="201168"/>
           </a:xfrm>
           <a:prstGeom prst="rect">
             <a:avLst/>
@@ -16832,24 +16832,24 @@
         </p:nvSpPr>
         <p:spPr>
           <a:xfrm>
-            <a:off x="731520" y="594360"/>
-            <a:ext cx="9601200" cy="438912"/>
-          </a:xfrm>
-          <a:prstGeom prst="rect">
-            <a:avLst/>
-          </a:prstGeom>
-          <a:noFill/>
-          <a:ln/>
-        </p:spPr>
-        <p:txBody>
-          <a:bodyPr wrap="square" rtlCol="0" anchor="ctr"/>
-          <a:lstStyle/>
-          <a:p>
-            <a:pPr indent="0" marL="0">
-              <a:buNone/>
-            </a:pPr>
-            <a:r>
-              <a:rPr lang="en-US" sz="1900" b="1" dirty="0">
+            <a:off x="731520" y="566928"/>
+            <a:ext cx="9601200" cy="402336"/>
+          </a:xfrm>
+          <a:prstGeom prst="rect">
+            <a:avLst/>
+          </a:prstGeom>
+          <a:noFill/>
+          <a:ln/>
+        </p:spPr>
+        <p:txBody>
+          <a:bodyPr wrap="square" rtlCol="0" anchor="ctr"/>
+          <a:lstStyle/>
+          <a:p>
+            <a:pPr indent="0" marL="0">
+              <a:buNone/>
+            </a:pPr>
+            <a:r>
+              <a:rPr lang="en-US" sz="1850" b="1" dirty="0">
                 <a:solidFill>
                   <a:srgbClr val="0F172A"/>
                 </a:solidFill>
@@ -16859,7 +16859,7 @@
               </a:rPr>
               <a:t>3 PERMOHONAN KEBIJAKAN NON-ANGGARAN KEPADA WALIKOTA</a:t>
             </a:r>
-            <a:endParaRPr lang="en-US" sz="1900" dirty="0"/>
+            <a:endParaRPr lang="en-US" sz="1850" dirty="0"/>
           </a:p>
         </p:txBody>
       </p:sp>
@@ -16871,24 +16871,24 @@
         </p:nvSpPr>
         <p:spPr>
           <a:xfrm>
-            <a:off x="731520" y="1024128"/>
-            <a:ext cx="9601200" cy="256032"/>
-          </a:xfrm>
-          <a:prstGeom prst="rect">
-            <a:avLst/>
-          </a:prstGeom>
-          <a:noFill/>
-          <a:ln/>
-        </p:spPr>
-        <p:txBody>
-          <a:bodyPr wrap="square" rtlCol="0" anchor="ctr"/>
-          <a:lstStyle/>
-          <a:p>
-            <a:pPr indent="0" marL="0">
-              <a:buNone/>
-            </a:pPr>
-            <a:r>
-              <a:rPr lang="en-US" sz="1050" i="1" dirty="0">
+            <a:off x="731520" y="1005840"/>
+            <a:ext cx="9601200" cy="237744"/>
+          </a:xfrm>
+          <a:prstGeom prst="rect">
+            <a:avLst/>
+          </a:prstGeom>
+          <a:noFill/>
+          <a:ln/>
+        </p:spPr>
+        <p:txBody>
+          <a:bodyPr wrap="square" rtlCol="0" anchor="ctr"/>
+          <a:lstStyle/>
+          <a:p>
+            <a:pPr indent="0" marL="0">
+              <a:buNone/>
+            </a:pPr>
+            <a:r>
+              <a:rPr lang="en-US" sz="1000" i="1" dirty="0">
                 <a:solidFill>
                   <a:srgbClr val="64748B"/>
                 </a:solidFill>
@@ -16898,7 +16898,7 @@
               </a:rPr>
               <a:t>Kami Tidak Memohon Tambahan Pagu APBD — Kami Memohon 3 Payung Regulasi Kepemimpinan Walikota</a:t>
             </a:r>
-            <a:endParaRPr lang="en-US" sz="1050" dirty="0"/>
+            <a:endParaRPr lang="en-US" sz="1000" dirty="0"/>
           </a:p>
         </p:txBody>
       </p:sp>
@@ -16910,8 +16910,8 @@
         </p:nvSpPr>
         <p:spPr>
           <a:xfrm>
-            <a:off x="10515600" y="438912"/>
-            <a:ext cx="914400" cy="228600"/>
+            <a:off x="10515600" y="329184"/>
+            <a:ext cx="914400" cy="201168"/>
           </a:xfrm>
           <a:prstGeom prst="rect">
             <a:avLst/>
@@ -18548,8 +18548,8 @@
         </p:nvSpPr>
         <p:spPr>
           <a:xfrm>
-            <a:off x="731520" y="384048"/>
-            <a:ext cx="9144000" cy="219456"/>
+            <a:off x="731520" y="329184"/>
+            <a:ext cx="9144000" cy="201168"/>
           </a:xfrm>
           <a:prstGeom prst="rect">
             <a:avLst/>
@@ -18587,24 +18587,24 @@
         </p:nvSpPr>
         <p:spPr>
           <a:xfrm>
-            <a:off x="731520" y="594360"/>
-            <a:ext cx="9601200" cy="438912"/>
-          </a:xfrm>
-          <a:prstGeom prst="rect">
-            <a:avLst/>
-          </a:prstGeom>
-          <a:noFill/>
-          <a:ln/>
-        </p:spPr>
-        <p:txBody>
-          <a:bodyPr wrap="square" rtlCol="0" anchor="ctr"/>
-          <a:lstStyle/>
-          <a:p>
-            <a:pPr indent="0" marL="0">
-              <a:buNone/>
-            </a:pPr>
-            <a:r>
-              <a:rPr lang="en-US" sz="1900" b="1" dirty="0">
+            <a:off x="731520" y="566928"/>
+            <a:ext cx="9601200" cy="402336"/>
+          </a:xfrm>
+          <a:prstGeom prst="rect">
+            <a:avLst/>
+          </a:prstGeom>
+          <a:noFill/>
+          <a:ln/>
+        </p:spPr>
+        <p:txBody>
+          <a:bodyPr wrap="square" rtlCol="0" anchor="ctr"/>
+          <a:lstStyle/>
+          <a:p>
+            <a:pPr indent="0" marL="0">
+              <a:buNone/>
+            </a:pPr>
+            <a:r>
+              <a:rPr lang="en-US" sz="1850" b="1" dirty="0">
                 <a:solidFill>
                   <a:srgbClr val="0F172A"/>
                 </a:solidFill>
@@ -18614,7 +18614,7 @@
               </a:rPr>
               <a:t>RENCANA AKSI 100 HARI PERTAMA: QUICK WINS PASCA-ARAHAN WALIKOTA</a:t>
             </a:r>
-            <a:endParaRPr lang="en-US" sz="1900" dirty="0"/>
+            <a:endParaRPr lang="en-US" sz="1850" dirty="0"/>
           </a:p>
         </p:txBody>
       </p:sp>
@@ -18626,24 +18626,24 @@
         </p:nvSpPr>
         <p:spPr>
           <a:xfrm>
-            <a:off x="731520" y="1024128"/>
-            <a:ext cx="9601200" cy="256032"/>
-          </a:xfrm>
-          <a:prstGeom prst="rect">
-            <a:avLst/>
-          </a:prstGeom>
-          <a:noFill/>
-          <a:ln/>
-        </p:spPr>
-        <p:txBody>
-          <a:bodyPr wrap="square" rtlCol="0" anchor="ctr"/>
-          <a:lstStyle/>
-          <a:p>
-            <a:pPr indent="0" marL="0">
-              <a:buNone/>
-            </a:pPr>
-            <a:r>
-              <a:rPr lang="en-US" sz="1050" i="1" dirty="0">
+            <a:off x="731520" y="1005840"/>
+            <a:ext cx="9601200" cy="237744"/>
+          </a:xfrm>
+          <a:prstGeom prst="rect">
+            <a:avLst/>
+          </a:prstGeom>
+          <a:noFill/>
+          <a:ln/>
+        </p:spPr>
+        <p:txBody>
+          <a:bodyPr wrap="square" rtlCol="0" anchor="ctr"/>
+          <a:lstStyle/>
+          <a:p>
+            <a:pPr indent="0" marL="0">
+              <a:buNone/>
+            </a:pPr>
+            <a:r>
+              <a:rPr lang="en-US" sz="1000" i="1" dirty="0">
                 <a:solidFill>
                   <a:srgbClr val="64748B"/>
                 </a:solidFill>
@@ -18653,7 +18653,7 @@
               </a:rPr>
               <a:t>Milestone Terukur, Matriks Penanggung Jawab, dan Output Nyata dalam 100 Hari Pasca-Persetujuan Kebijakan</a:t>
             </a:r>
-            <a:endParaRPr lang="en-US" sz="1050" dirty="0"/>
+            <a:endParaRPr lang="en-US" sz="1000" dirty="0"/>
           </a:p>
         </p:txBody>
       </p:sp>
@@ -18665,8 +18665,8 @@
         </p:nvSpPr>
         <p:spPr>
           <a:xfrm>
-            <a:off x="10515600" y="438912"/>
-            <a:ext cx="914400" cy="228600"/>
+            <a:off x="10515600" y="329184"/>
+            <a:ext cx="914400" cy="201168"/>
           </a:xfrm>
           <a:prstGeom prst="rect">
             <a:avLst/>
@@ -20910,8 +20910,8 @@
         </p:nvSpPr>
         <p:spPr>
           <a:xfrm>
-            <a:off x="731520" y="384048"/>
-            <a:ext cx="9144000" cy="219456"/>
+            <a:off x="731520" y="329184"/>
+            <a:ext cx="9144000" cy="201168"/>
           </a:xfrm>
           <a:prstGeom prst="rect">
             <a:avLst/>
@@ -20949,24 +20949,24 @@
         </p:nvSpPr>
         <p:spPr>
           <a:xfrm>
-            <a:off x="731520" y="594360"/>
-            <a:ext cx="9601200" cy="438912"/>
-          </a:xfrm>
-          <a:prstGeom prst="rect">
-            <a:avLst/>
-          </a:prstGeom>
-          <a:noFill/>
-          <a:ln/>
-        </p:spPr>
-        <p:txBody>
-          <a:bodyPr wrap="square" rtlCol="0" anchor="ctr"/>
-          <a:lstStyle/>
-          <a:p>
-            <a:pPr indent="0" marL="0">
-              <a:buNone/>
-            </a:pPr>
-            <a:r>
-              <a:rPr lang="en-US" sz="1900" b="1" dirty="0">
+            <a:off x="731520" y="566928"/>
+            <a:ext cx="9601200" cy="402336"/>
+          </a:xfrm>
+          <a:prstGeom prst="rect">
+            <a:avLst/>
+          </a:prstGeom>
+          <a:noFill/>
+          <a:ln/>
+        </p:spPr>
+        <p:txBody>
+          <a:bodyPr wrap="square" rtlCol="0" anchor="ctr"/>
+          <a:lstStyle/>
+          <a:p>
+            <a:pPr indent="0" marL="0">
+              <a:buNone/>
+            </a:pPr>
+            <a:r>
+              <a:rPr lang="en-US" sz="1850" b="1" dirty="0">
                 <a:solidFill>
                   <a:srgbClr val="0F172A"/>
                 </a:solidFill>
@@ -20976,7 +20976,7 @@
               </a:rPr>
               <a:t>KEDUDUKAN HUKUM UPTD KST SOLO TECHNOPARK DI BAWAH BRIDA</a:t>
             </a:r>
-            <a:endParaRPr lang="en-US" sz="1900" dirty="0"/>
+            <a:endParaRPr lang="en-US" sz="1850" dirty="0"/>
           </a:p>
         </p:txBody>
       </p:sp>
@@ -20988,24 +20988,24 @@
         </p:nvSpPr>
         <p:spPr>
           <a:xfrm>
-            <a:off x="731520" y="1024128"/>
-            <a:ext cx="9601200" cy="256032"/>
-          </a:xfrm>
-          <a:prstGeom prst="rect">
-            <a:avLst/>
-          </a:prstGeom>
-          <a:noFill/>
-          <a:ln/>
-        </p:spPr>
-        <p:txBody>
-          <a:bodyPr wrap="square" rtlCol="0" anchor="ctr"/>
-          <a:lstStyle/>
-          <a:p>
-            <a:pPr indent="0" marL="0">
-              <a:buNone/>
-            </a:pPr>
-            <a:r>
-              <a:rPr lang="en-US" sz="1050" i="1" dirty="0">
+            <a:off x="731520" y="1005840"/>
+            <a:ext cx="9601200" cy="237744"/>
+          </a:xfrm>
+          <a:prstGeom prst="rect">
+            <a:avLst/>
+          </a:prstGeom>
+          <a:noFill/>
+          <a:ln/>
+        </p:spPr>
+        <p:txBody>
+          <a:bodyPr wrap="square" rtlCol="0" anchor="ctr"/>
+          <a:lstStyle/>
+          <a:p>
+            <a:pPr indent="0" marL="0">
+              <a:buNone/>
+            </a:pPr>
+            <a:r>
+              <a:rPr lang="en-US" sz="1000" i="1" dirty="0">
                 <a:solidFill>
                   <a:srgbClr val="64748B"/>
                 </a:solidFill>
@@ -21015,7 +21015,7 @@
               </a:rPr>
               <a:t>Landasan Struktural Berdasarkan Peraturan Walikota Surakarta No. 15 Tahun 2022</a:t>
             </a:r>
-            <a:endParaRPr lang="en-US" sz="1050" dirty="0"/>
+            <a:endParaRPr lang="en-US" sz="1000" dirty="0"/>
           </a:p>
         </p:txBody>
       </p:sp>
@@ -21027,8 +21027,8 @@
         </p:nvSpPr>
         <p:spPr>
           <a:xfrm>
-            <a:off x="10515600" y="438912"/>
-            <a:ext cx="914400" cy="228600"/>
+            <a:off x="10515600" y="329184"/>
+            <a:ext cx="914400" cy="201168"/>
           </a:xfrm>
           <a:prstGeom prst="rect">
             <a:avLst/>
@@ -23226,8 +23226,8 @@
         </p:nvSpPr>
         <p:spPr>
           <a:xfrm>
-            <a:off x="731520" y="384048"/>
-            <a:ext cx="9144000" cy="219456"/>
+            <a:off x="731520" y="329184"/>
+            <a:ext cx="9144000" cy="201168"/>
           </a:xfrm>
           <a:prstGeom prst="rect">
             <a:avLst/>
@@ -23265,24 +23265,24 @@
         </p:nvSpPr>
         <p:spPr>
           <a:xfrm>
-            <a:off x="731520" y="594360"/>
-            <a:ext cx="9601200" cy="438912"/>
-          </a:xfrm>
-          <a:prstGeom prst="rect">
-            <a:avLst/>
-          </a:prstGeom>
-          <a:noFill/>
-          <a:ln/>
-        </p:spPr>
-        <p:txBody>
-          <a:bodyPr wrap="square" rtlCol="0" anchor="ctr"/>
-          <a:lstStyle/>
-          <a:p>
-            <a:pPr indent="0" marL="0">
-              <a:buNone/>
-            </a:pPr>
-            <a:r>
-              <a:rPr lang="en-US" sz="1900" b="1" dirty="0">
+            <a:off x="731520" y="566928"/>
+            <a:ext cx="9601200" cy="402336"/>
+          </a:xfrm>
+          <a:prstGeom prst="rect">
+            <a:avLst/>
+          </a:prstGeom>
+          <a:noFill/>
+          <a:ln/>
+        </p:spPr>
+        <p:txBody>
+          <a:bodyPr wrap="square" rtlCol="0" anchor="ctr"/>
+          <a:lstStyle/>
+          <a:p>
+            <a:pPr indent="0" marL="0">
+              <a:buNone/>
+            </a:pPr>
+            <a:r>
+              <a:rPr lang="en-US" sz="1850" b="1" dirty="0">
                 <a:solidFill>
                   <a:srgbClr val="0F172A"/>
                 </a:solidFill>
@@ -23292,7 +23292,7 @@
               </a:rPr>
               <a:t>RANTAI DAMPAK SOLO TECHNOPARK UNTUK WARGA SURAKARTA</a:t>
             </a:r>
-            <a:endParaRPr lang="en-US" sz="1900" dirty="0"/>
+            <a:endParaRPr lang="en-US" sz="1850" dirty="0"/>
           </a:p>
         </p:txBody>
       </p:sp>
@@ -23304,24 +23304,24 @@
         </p:nvSpPr>
         <p:spPr>
           <a:xfrm>
-            <a:off x="731520" y="1024128"/>
-            <a:ext cx="9601200" cy="256032"/>
-          </a:xfrm>
-          <a:prstGeom prst="rect">
-            <a:avLst/>
-          </a:prstGeom>
-          <a:noFill/>
-          <a:ln/>
-        </p:spPr>
-        <p:txBody>
-          <a:bodyPr wrap="square" rtlCol="0" anchor="ctr"/>
-          <a:lstStyle/>
-          <a:p>
-            <a:pPr indent="0" marL="0">
-              <a:buNone/>
-            </a:pPr>
-            <a:r>
-              <a:rPr lang="en-US" sz="1050" i="1" dirty="0">
+            <a:off x="731520" y="1005840"/>
+            <a:ext cx="9601200" cy="237744"/>
+          </a:xfrm>
+          <a:prstGeom prst="rect">
+            <a:avLst/>
+          </a:prstGeom>
+          <a:noFill/>
+          <a:ln/>
+        </p:spPr>
+        <p:txBody>
+          <a:bodyPr wrap="square" rtlCol="0" anchor="ctr"/>
+          <a:lstStyle/>
+          <a:p>
+            <a:pPr indent="0" marL="0">
+              <a:buNone/>
+            </a:pPr>
+            <a:r>
+              <a:rPr lang="en-US" sz="1000" i="1" dirty="0">
                 <a:solidFill>
                   <a:srgbClr val="64748B"/>
                 </a:solidFill>
@@ -23331,7 +23331,7 @@
               </a:rPr>
               <a:t>Menjembatani Hasil Riset Laboratorium Menjadi Nilai Ekonomi Riil dan Lapangan Kerja Daerah</a:t>
             </a:r>
-            <a:endParaRPr lang="en-US" sz="1050" dirty="0"/>
+            <a:endParaRPr lang="en-US" sz="1000" dirty="0"/>
           </a:p>
         </p:txBody>
       </p:sp>
@@ -23343,8 +23343,8 @@
         </p:nvSpPr>
         <p:spPr>
           <a:xfrm>
-            <a:off x="10515600" y="438912"/>
-            <a:ext cx="914400" cy="228600"/>
+            <a:off x="10515600" y="329184"/>
+            <a:ext cx="914400" cy="201168"/>
           </a:xfrm>
           <a:prstGeom prst="rect">
             <a:avLst/>
@@ -25497,8 +25497,8 @@
         </p:nvSpPr>
         <p:spPr>
           <a:xfrm>
-            <a:off x="731520" y="384048"/>
-            <a:ext cx="9144000" cy="219456"/>
+            <a:off x="731520" y="329184"/>
+            <a:ext cx="9144000" cy="201168"/>
           </a:xfrm>
           <a:prstGeom prst="rect">
             <a:avLst/>
@@ -25536,24 +25536,24 @@
         </p:nvSpPr>
         <p:spPr>
           <a:xfrm>
-            <a:off x="731520" y="594360"/>
-            <a:ext cx="9601200" cy="438912"/>
-          </a:xfrm>
-          <a:prstGeom prst="rect">
-            <a:avLst/>
-          </a:prstGeom>
-          <a:noFill/>
-          <a:ln/>
-        </p:spPr>
-        <p:txBody>
-          <a:bodyPr wrap="square" rtlCol="0" anchor="ctr"/>
-          <a:lstStyle/>
-          <a:p>
-            <a:pPr indent="0" marL="0">
-              <a:buNone/>
-            </a:pPr>
-            <a:r>
-              <a:rPr lang="en-US" sz="1900" b="1" dirty="0">
+            <a:off x="731520" y="566928"/>
+            <a:ext cx="9601200" cy="402336"/>
+          </a:xfrm>
+          <a:prstGeom prst="rect">
+            <a:avLst/>
+          </a:prstGeom>
+          <a:noFill/>
+          <a:ln/>
+        </p:spPr>
+        <p:txBody>
+          <a:bodyPr wrap="square" rtlCol="0" anchor="ctr"/>
+          <a:lstStyle/>
+          <a:p>
+            <a:pPr indent="0" marL="0">
+              <a:buNone/>
+            </a:pPr>
+            <a:r>
+              <a:rPr lang="en-US" sz="1850" b="1" dirty="0">
                 <a:solidFill>
                   <a:srgbClr val="0F172A"/>
                 </a:solidFill>
@@ -25563,7 +25563,7 @@
               </a:rPr>
               <a:t>LANDASAN YURIDIS KOKOH &amp; 4 FLEKSIBILITAS PENGELOLAAN BLUD</a:t>
             </a:r>
-            <a:endParaRPr lang="en-US" sz="1900" dirty="0"/>
+            <a:endParaRPr lang="en-US" sz="1850" dirty="0"/>
           </a:p>
         </p:txBody>
       </p:sp>
@@ -25575,24 +25575,24 @@
         </p:nvSpPr>
         <p:spPr>
           <a:xfrm>
-            <a:off x="731520" y="1024128"/>
-            <a:ext cx="9601200" cy="256032"/>
-          </a:xfrm>
-          <a:prstGeom prst="rect">
-            <a:avLst/>
-          </a:prstGeom>
-          <a:noFill/>
-          <a:ln/>
-        </p:spPr>
-        <p:txBody>
-          <a:bodyPr wrap="square" rtlCol="0" anchor="ctr"/>
-          <a:lstStyle/>
-          <a:p>
-            <a:pPr indent="0" marL="0">
-              <a:buNone/>
-            </a:pPr>
-            <a:r>
-              <a:rPr lang="en-US" sz="1050" i="1" dirty="0">
+            <a:off x="731520" y="1005840"/>
+            <a:ext cx="9601200" cy="237744"/>
+          </a:xfrm>
+          <a:prstGeom prst="rect">
+            <a:avLst/>
+          </a:prstGeom>
+          <a:noFill/>
+          <a:ln/>
+        </p:spPr>
+        <p:txBody>
+          <a:bodyPr wrap="square" rtlCol="0" anchor="ctr"/>
+          <a:lstStyle/>
+          <a:p>
+            <a:pPr indent="0" marL="0">
+              <a:buNone/>
+            </a:pPr>
+            <a:r>
+              <a:rPr lang="en-US" sz="1000" i="1" dirty="0">
                 <a:solidFill>
                   <a:srgbClr val="64748B"/>
                 </a:solidFill>
@@ -25602,7 +25602,7 @@
               </a:rPr>
               <a:t>Menjamin Kepatuhan Tata Kelola Pemerintahan Sekaligus Kelincahan Kemitraan Komersial</a:t>
             </a:r>
-            <a:endParaRPr lang="en-US" sz="1050" dirty="0"/>
+            <a:endParaRPr lang="en-US" sz="1000" dirty="0"/>
           </a:p>
         </p:txBody>
       </p:sp>
@@ -25614,8 +25614,8 @@
         </p:nvSpPr>
         <p:spPr>
           <a:xfrm>
-            <a:off x="10515600" y="438912"/>
-            <a:ext cx="914400" cy="228600"/>
+            <a:off x="10515600" y="329184"/>
+            <a:ext cx="914400" cy="201168"/>
           </a:xfrm>
           <a:prstGeom prst="rect">
             <a:avLst/>
@@ -25677,7 +25677,7 @@
         <p:spPr>
           <a:xfrm>
             <a:off x="731520" y="1508760"/>
-            <a:ext cx="4023360" cy="4023360"/>
+            <a:ext cx="4114800" cy="4023360"/>
           </a:xfrm>
           <a:prstGeom prst="rect">
             <a:avLst/>
@@ -25702,7 +25702,7 @@
         <p:spPr>
           <a:xfrm>
             <a:off x="731520" y="1508760"/>
-            <a:ext cx="4023360" cy="73152"/>
+            <a:ext cx="4114800" cy="73152"/>
           </a:xfrm>
           <a:prstGeom prst="rect">
             <a:avLst/>
@@ -25727,7 +25727,7 @@
         <p:spPr>
           <a:xfrm>
             <a:off x="960120" y="1691640"/>
-            <a:ext cx="3566160" cy="228600"/>
+            <a:ext cx="3657600" cy="228600"/>
           </a:xfrm>
           <a:prstGeom prst="rect">
             <a:avLst/>
@@ -25821,7 +25821,7 @@
         <p:spPr>
           <a:xfrm>
             <a:off x="1371600" y="2029968"/>
-            <a:ext cx="3200400" cy="228600"/>
+            <a:ext cx="3291840" cy="228600"/>
           </a:xfrm>
           <a:prstGeom prst="rect">
             <a:avLst/>
@@ -25860,7 +25860,7 @@
         <p:spPr>
           <a:xfrm>
             <a:off x="1371600" y="2267712"/>
-            <a:ext cx="3200400" cy="548640"/>
+            <a:ext cx="3291840" cy="548640"/>
           </a:xfrm>
           <a:prstGeom prst="rect">
             <a:avLst/>
@@ -25957,7 +25957,7 @@
         <p:spPr>
           <a:xfrm>
             <a:off x="1371600" y="2871216"/>
-            <a:ext cx="3200400" cy="228600"/>
+            <a:ext cx="3291840" cy="228600"/>
           </a:xfrm>
           <a:prstGeom prst="rect">
             <a:avLst/>
@@ -25996,7 +25996,7 @@
         <p:spPr>
           <a:xfrm>
             <a:off x="1371600" y="3108960"/>
-            <a:ext cx="3200400" cy="548640"/>
+            <a:ext cx="3291840" cy="548640"/>
           </a:xfrm>
           <a:prstGeom prst="rect">
             <a:avLst/>
@@ -26093,7 +26093,7 @@
         <p:spPr>
           <a:xfrm>
             <a:off x="1371600" y="3712464"/>
-            <a:ext cx="3200400" cy="228600"/>
+            <a:ext cx="3291840" cy="228600"/>
           </a:xfrm>
           <a:prstGeom prst="rect">
             <a:avLst/>
@@ -26132,7 +26132,7 @@
         <p:spPr>
           <a:xfrm>
             <a:off x="1371600" y="3950208"/>
-            <a:ext cx="3200400" cy="548640"/>
+            <a:ext cx="3291840" cy="548640"/>
           </a:xfrm>
           <a:prstGeom prst="rect">
             <a:avLst/>
@@ -26229,7 +26229,7 @@
         <p:spPr>
           <a:xfrm>
             <a:off x="1371600" y="4553712"/>
-            <a:ext cx="3200400" cy="228600"/>
+            <a:ext cx="3291840" cy="228600"/>
           </a:xfrm>
           <a:prstGeom prst="rect">
             <a:avLst/>
@@ -26268,7 +26268,7 @@
         <p:spPr>
           <a:xfrm>
             <a:off x="1371600" y="4791456"/>
-            <a:ext cx="3200400" cy="548640"/>
+            <a:ext cx="3291840" cy="548640"/>
           </a:xfrm>
           <a:prstGeom prst="rect">
             <a:avLst/>
@@ -26309,7 +26309,7 @@
         </p:nvSpPr>
         <p:spPr>
           <a:xfrm>
-            <a:off x="4983480" y="1508760"/>
+            <a:off x="5059375" y="1508760"/>
             <a:ext cx="3108960" cy="1965960"/>
           </a:xfrm>
           <a:prstGeom prst="rect">
@@ -26334,7 +26334,7 @@
         </p:nvSpPr>
         <p:spPr>
           <a:xfrm>
-            <a:off x="4983480" y="1508760"/>
+            <a:off x="5059375" y="1508760"/>
             <a:ext cx="3108960" cy="73152"/>
           </a:xfrm>
           <a:prstGeom prst="rect">
@@ -26359,7 +26359,7 @@
         </p:nvSpPr>
         <p:spPr>
           <a:xfrm>
-            <a:off x="5166360" y="1673352"/>
+            <a:off x="5242255" y="1673352"/>
             <a:ext cx="438912" cy="438912"/>
           </a:xfrm>
           <a:prstGeom prst="rect">
@@ -26398,7 +26398,7 @@
         </p:blipFill>
         <p:spPr>
           <a:xfrm>
-            <a:off x="5239512" y="1746504"/>
+            <a:off x="5315407" y="1746504"/>
             <a:ext cx="292608" cy="292608"/>
           </a:xfrm>
           <a:prstGeom prst="rect">
@@ -26414,7 +26414,7 @@
         </p:nvSpPr>
         <p:spPr>
           <a:xfrm>
-            <a:off x="5577840" y="1655064"/>
+            <a:off x="5653735" y="1655064"/>
             <a:ext cx="2377440" cy="219456"/>
           </a:xfrm>
           <a:prstGeom prst="rect">
@@ -26453,7 +26453,7 @@
         </p:nvSpPr>
         <p:spPr>
           <a:xfrm>
-            <a:off x="5577840" y="1874520"/>
+            <a:off x="5653735" y="1874520"/>
             <a:ext cx="2377440" cy="182880"/>
           </a:xfrm>
           <a:prstGeom prst="rect">
@@ -26492,7 +26492,7 @@
         </p:nvSpPr>
         <p:spPr>
           <a:xfrm>
-            <a:off x="5166360" y="2130552"/>
+            <a:off x="5242255" y="2130552"/>
             <a:ext cx="2743200" cy="0"/>
           </a:xfrm>
           <a:prstGeom prst="line">
@@ -26515,7 +26515,7 @@
         </p:nvSpPr>
         <p:spPr>
           <a:xfrm>
-            <a:off x="5166360" y="2221992"/>
+            <a:off x="5242255" y="2221992"/>
             <a:ext cx="73152" cy="73152"/>
           </a:xfrm>
           <a:prstGeom prst="ellipse">
@@ -26540,7 +26540,7 @@
         </p:nvSpPr>
         <p:spPr>
           <a:xfrm>
-            <a:off x="5303520" y="2185416"/>
+            <a:off x="5379415" y="2185416"/>
             <a:ext cx="2606040" cy="530352"/>
           </a:xfrm>
           <a:prstGeom prst="rect">
@@ -26582,7 +26582,7 @@
         </p:nvSpPr>
         <p:spPr>
           <a:xfrm>
-            <a:off x="5166360" y="2788920"/>
+            <a:off x="5242255" y="2788920"/>
             <a:ext cx="73152" cy="73152"/>
           </a:xfrm>
           <a:prstGeom prst="ellipse">
@@ -26607,7 +26607,7 @@
         </p:nvSpPr>
         <p:spPr>
           <a:xfrm>
-            <a:off x="5303520" y="2752344"/>
+            <a:off x="5379415" y="2752344"/>
             <a:ext cx="2606040" cy="530352"/>
           </a:xfrm>
           <a:prstGeom prst="rect">
@@ -26649,7 +26649,7 @@
         </p:nvSpPr>
         <p:spPr>
           <a:xfrm>
-            <a:off x="8229600" y="1508760"/>
+            <a:off x="8351215" y="1508760"/>
             <a:ext cx="3108960" cy="1965960"/>
           </a:xfrm>
           <a:prstGeom prst="rect">
@@ -26674,7 +26674,7 @@
         </p:nvSpPr>
         <p:spPr>
           <a:xfrm>
-            <a:off x="8229600" y="1508760"/>
+            <a:off x="8351215" y="1508760"/>
             <a:ext cx="3108960" cy="73152"/>
           </a:xfrm>
           <a:prstGeom prst="rect">
@@ -26699,7 +26699,7 @@
         </p:nvSpPr>
         <p:spPr>
           <a:xfrm>
-            <a:off x="8412480" y="1673352"/>
+            <a:off x="8534095" y="1673352"/>
             <a:ext cx="438912" cy="438912"/>
           </a:xfrm>
           <a:prstGeom prst="rect">
@@ -26738,7 +26738,7 @@
         </p:blipFill>
         <p:spPr>
           <a:xfrm>
-            <a:off x="8485632" y="1746504"/>
+            <a:off x="8607247" y="1746504"/>
             <a:ext cx="292608" cy="292608"/>
           </a:xfrm>
           <a:prstGeom prst="rect">
@@ -26754,7 +26754,7 @@
         </p:nvSpPr>
         <p:spPr>
           <a:xfrm>
-            <a:off x="8823960" y="1655064"/>
+            <a:off x="8945575" y="1655064"/>
             <a:ext cx="2377440" cy="219456"/>
           </a:xfrm>
           <a:prstGeom prst="rect">
@@ -26793,7 +26793,7 @@
         </p:nvSpPr>
         <p:spPr>
           <a:xfrm>
-            <a:off x="8823960" y="1874520"/>
+            <a:off x="8945575" y="1874520"/>
             <a:ext cx="2377440" cy="182880"/>
           </a:xfrm>
           <a:prstGeom prst="rect">
@@ -26832,7 +26832,7 @@
         </p:nvSpPr>
         <p:spPr>
           <a:xfrm>
-            <a:off x="8412480" y="2130552"/>
+            <a:off x="8534095" y="2130552"/>
             <a:ext cx="2743200" cy="0"/>
           </a:xfrm>
           <a:prstGeom prst="line">
@@ -26855,7 +26855,7 @@
         </p:nvSpPr>
         <p:spPr>
           <a:xfrm>
-            <a:off x="8412480" y="2221992"/>
+            <a:off x="8534095" y="2221992"/>
             <a:ext cx="73152" cy="73152"/>
           </a:xfrm>
           <a:prstGeom prst="ellipse">
@@ -26880,7 +26880,7 @@
         </p:nvSpPr>
         <p:spPr>
           <a:xfrm>
-            <a:off x="8549640" y="2185416"/>
+            <a:off x="8671255" y="2185416"/>
             <a:ext cx="2606040" cy="530352"/>
           </a:xfrm>
           <a:prstGeom prst="rect">
@@ -26922,7 +26922,7 @@
         </p:nvSpPr>
         <p:spPr>
           <a:xfrm>
-            <a:off x="8412480" y="2788920"/>
+            <a:off x="8534095" y="2788920"/>
             <a:ext cx="73152" cy="73152"/>
           </a:xfrm>
           <a:prstGeom prst="ellipse">
@@ -26947,7 +26947,7 @@
         </p:nvSpPr>
         <p:spPr>
           <a:xfrm>
-            <a:off x="8549640" y="2752344"/>
+            <a:off x="8671255" y="2752344"/>
             <a:ext cx="2606040" cy="530352"/>
           </a:xfrm>
           <a:prstGeom prst="rect">
@@ -26989,7 +26989,7 @@
         </p:nvSpPr>
         <p:spPr>
           <a:xfrm>
-            <a:off x="4983480" y="3566160"/>
+            <a:off x="5059375" y="3566160"/>
             <a:ext cx="3108960" cy="1965960"/>
           </a:xfrm>
           <a:prstGeom prst="rect">
@@ -27014,7 +27014,7 @@
         </p:nvSpPr>
         <p:spPr>
           <a:xfrm>
-            <a:off x="4983480" y="3566160"/>
+            <a:off x="5059375" y="3566160"/>
             <a:ext cx="3108960" cy="73152"/>
           </a:xfrm>
           <a:prstGeom prst="rect">
@@ -27039,7 +27039,7 @@
         </p:nvSpPr>
         <p:spPr>
           <a:xfrm>
-            <a:off x="5166360" y="3730752"/>
+            <a:off x="5242255" y="3730752"/>
             <a:ext cx="438912" cy="438912"/>
           </a:xfrm>
           <a:prstGeom prst="rect">
@@ -27078,7 +27078,7 @@
         </p:blipFill>
         <p:spPr>
           <a:xfrm>
-            <a:off x="5239512" y="3803904"/>
+            <a:off x="5315407" y="3803904"/>
             <a:ext cx="292608" cy="292608"/>
           </a:xfrm>
           <a:prstGeom prst="rect">
@@ -27094,7 +27094,7 @@
         </p:nvSpPr>
         <p:spPr>
           <a:xfrm>
-            <a:off x="5577840" y="3712464"/>
+            <a:off x="5653735" y="3712464"/>
             <a:ext cx="2377440" cy="219456"/>
           </a:xfrm>
           <a:prstGeom prst="rect">
@@ -27133,7 +27133,7 @@
         </p:nvSpPr>
         <p:spPr>
           <a:xfrm>
-            <a:off x="5577840" y="3931920"/>
+            <a:off x="5653735" y="3931920"/>
             <a:ext cx="2377440" cy="182880"/>
           </a:xfrm>
           <a:prstGeom prst="rect">
@@ -27172,7 +27172,7 @@
         </p:nvSpPr>
         <p:spPr>
           <a:xfrm>
-            <a:off x="5166360" y="4187952"/>
+            <a:off x="5242255" y="4187952"/>
             <a:ext cx="2743200" cy="0"/>
           </a:xfrm>
           <a:prstGeom prst="line">
@@ -27195,7 +27195,7 @@
         </p:nvSpPr>
         <p:spPr>
           <a:xfrm>
-            <a:off x="5166360" y="4279392"/>
+            <a:off x="5242255" y="4279392"/>
             <a:ext cx="73152" cy="73152"/>
           </a:xfrm>
           <a:prstGeom prst="ellipse">
@@ -27220,7 +27220,7 @@
         </p:nvSpPr>
         <p:spPr>
           <a:xfrm>
-            <a:off x="5303520" y="4242816"/>
+            <a:off x="5379415" y="4242816"/>
             <a:ext cx="2606040" cy="530352"/>
           </a:xfrm>
           <a:prstGeom prst="rect">
@@ -27262,7 +27262,7 @@
         </p:nvSpPr>
         <p:spPr>
           <a:xfrm>
-            <a:off x="5166360" y="4846320"/>
+            <a:off x="5242255" y="4846320"/>
             <a:ext cx="73152" cy="73152"/>
           </a:xfrm>
           <a:prstGeom prst="ellipse">
@@ -27287,7 +27287,7 @@
         </p:nvSpPr>
         <p:spPr>
           <a:xfrm>
-            <a:off x="5303520" y="4809744"/>
+            <a:off x="5379415" y="4809744"/>
             <a:ext cx="2606040" cy="530352"/>
           </a:xfrm>
           <a:prstGeom prst="rect">
@@ -27329,7 +27329,7 @@
         </p:nvSpPr>
         <p:spPr>
           <a:xfrm>
-            <a:off x="8229600" y="3566160"/>
+            <a:off x="8351215" y="3566160"/>
             <a:ext cx="3108960" cy="1965960"/>
           </a:xfrm>
           <a:prstGeom prst="rect">
@@ -27354,7 +27354,7 @@
         </p:nvSpPr>
         <p:spPr>
           <a:xfrm>
-            <a:off x="8229600" y="3566160"/>
+            <a:off x="8351215" y="3566160"/>
             <a:ext cx="3108960" cy="73152"/>
           </a:xfrm>
           <a:prstGeom prst="rect">
@@ -27379,7 +27379,7 @@
         </p:nvSpPr>
         <p:spPr>
           <a:xfrm>
-            <a:off x="8412480" y="3730752"/>
+            <a:off x="8534095" y="3730752"/>
             <a:ext cx="438912" cy="438912"/>
           </a:xfrm>
           <a:prstGeom prst="rect">
@@ -27418,7 +27418,7 @@
         </p:blipFill>
         <p:spPr>
           <a:xfrm>
-            <a:off x="8485632" y="3803904"/>
+            <a:off x="8607247" y="3803904"/>
             <a:ext cx="292608" cy="292608"/>
           </a:xfrm>
           <a:prstGeom prst="rect">
@@ -27434,7 +27434,7 @@
         </p:nvSpPr>
         <p:spPr>
           <a:xfrm>
-            <a:off x="8823960" y="3712464"/>
+            <a:off x="8945575" y="3712464"/>
             <a:ext cx="2377440" cy="219456"/>
           </a:xfrm>
           <a:prstGeom prst="rect">
@@ -27473,7 +27473,7 @@
         </p:nvSpPr>
         <p:spPr>
           <a:xfrm>
-            <a:off x="8823960" y="3931920"/>
+            <a:off x="8945575" y="3931920"/>
             <a:ext cx="2377440" cy="182880"/>
           </a:xfrm>
           <a:prstGeom prst="rect">
@@ -27512,7 +27512,7 @@
         </p:nvSpPr>
         <p:spPr>
           <a:xfrm>
-            <a:off x="8412480" y="4187952"/>
+            <a:off x="8534095" y="4187952"/>
             <a:ext cx="2743200" cy="0"/>
           </a:xfrm>
           <a:prstGeom prst="line">
@@ -27535,7 +27535,7 @@
         </p:nvSpPr>
         <p:spPr>
           <a:xfrm>
-            <a:off x="8412480" y="4279392"/>
+            <a:off x="8534095" y="4279392"/>
             <a:ext cx="73152" cy="73152"/>
           </a:xfrm>
           <a:prstGeom prst="ellipse">
@@ -27560,7 +27560,7 @@
         </p:nvSpPr>
         <p:spPr>
           <a:xfrm>
-            <a:off x="8549640" y="4242816"/>
+            <a:off x="8671255" y="4242816"/>
             <a:ext cx="2606040" cy="530352"/>
           </a:xfrm>
           <a:prstGeom prst="rect">
@@ -27602,7 +27602,7 @@
         </p:nvSpPr>
         <p:spPr>
           <a:xfrm>
-            <a:off x="8412480" y="4846320"/>
+            <a:off x="8534095" y="4846320"/>
             <a:ext cx="73152" cy="73152"/>
           </a:xfrm>
           <a:prstGeom prst="ellipse">
@@ -27627,7 +27627,7 @@
         </p:nvSpPr>
         <p:spPr>
           <a:xfrm>
-            <a:off x="8549640" y="4809744"/>
+            <a:off x="8671255" y="4809744"/>
             <a:ext cx="2606040" cy="530352"/>
           </a:xfrm>
           <a:prstGeom prst="rect">
@@ -27862,8 +27862,8 @@
         </p:nvSpPr>
         <p:spPr>
           <a:xfrm>
-            <a:off x="731520" y="384048"/>
-            <a:ext cx="9144000" cy="219456"/>
+            <a:off x="731520" y="329184"/>
+            <a:ext cx="9144000" cy="201168"/>
           </a:xfrm>
           <a:prstGeom prst="rect">
             <a:avLst/>
@@ -27901,24 +27901,24 @@
         </p:nvSpPr>
         <p:spPr>
           <a:xfrm>
-            <a:off x="731520" y="594360"/>
-            <a:ext cx="9601200" cy="438912"/>
-          </a:xfrm>
-          <a:prstGeom prst="rect">
-            <a:avLst/>
-          </a:prstGeom>
-          <a:noFill/>
-          <a:ln/>
-        </p:spPr>
-        <p:txBody>
-          <a:bodyPr wrap="square" rtlCol="0" anchor="ctr"/>
-          <a:lstStyle/>
-          <a:p>
-            <a:pPr indent="0" marL="0">
-              <a:buNone/>
-            </a:pPr>
-            <a:r>
-              <a:rPr lang="en-US" sz="1900" b="1" dirty="0">
+            <a:off x="731520" y="566928"/>
+            <a:ext cx="9601200" cy="402336"/>
+          </a:xfrm>
+          <a:prstGeom prst="rect">
+            <a:avLst/>
+          </a:prstGeom>
+          <a:noFill/>
+          <a:ln/>
+        </p:spPr>
+        <p:txBody>
+          <a:bodyPr wrap="square" rtlCol="0" anchor="ctr"/>
+          <a:lstStyle/>
+          <a:p>
+            <a:pPr indent="0" marL="0">
+              <a:buNone/>
+            </a:pPr>
+            <a:r>
+              <a:rPr lang="en-US" sz="1850" b="1" dirty="0">
                 <a:solidFill>
                   <a:srgbClr val="0F172A"/>
                 </a:solidFill>
@@ -27928,7 +27928,7 @@
               </a:rPr>
               <a:t>EMPAT PILAR LAYANAN TERPADU SOLO TECHNOPARK</a:t>
             </a:r>
-            <a:endParaRPr lang="en-US" sz="1900" dirty="0"/>
+            <a:endParaRPr lang="en-US" sz="1850" dirty="0"/>
           </a:p>
         </p:txBody>
       </p:sp>
@@ -27940,24 +27940,24 @@
         </p:nvSpPr>
         <p:spPr>
           <a:xfrm>
-            <a:off x="731520" y="1024128"/>
-            <a:ext cx="9601200" cy="256032"/>
-          </a:xfrm>
-          <a:prstGeom prst="rect">
-            <a:avLst/>
-          </a:prstGeom>
-          <a:noFill/>
-          <a:ln/>
-        </p:spPr>
-        <p:txBody>
-          <a:bodyPr wrap="square" rtlCol="0" anchor="ctr"/>
-          <a:lstStyle/>
-          <a:p>
-            <a:pPr indent="0" marL="0">
-              <a:buNone/>
-            </a:pPr>
-            <a:r>
-              <a:rPr lang="en-US" sz="1050" i="1" dirty="0">
+            <a:off x="731520" y="1005840"/>
+            <a:ext cx="9601200" cy="237744"/>
+          </a:xfrm>
+          <a:prstGeom prst="rect">
+            <a:avLst/>
+          </a:prstGeom>
+          <a:noFill/>
+          <a:ln/>
+        </p:spPr>
+        <p:txBody>
+          <a:bodyPr wrap="square" rtlCol="0" anchor="ctr"/>
+          <a:lstStyle/>
+          <a:p>
+            <a:pPr indent="0" marL="0">
+              <a:buNone/>
+            </a:pPr>
+            <a:r>
+              <a:rPr lang="en-US" sz="1000" i="1" dirty="0">
                 <a:solidFill>
                   <a:srgbClr val="64748B"/>
                 </a:solidFill>
@@ -27967,7 +27967,7 @@
               </a:rPr>
               <a:t>Mandat Nasional Pengembangan KST sebagai Mesin Hilirisasi dan Pertumbuhan Ekonomi Daerah</a:t>
             </a:r>
-            <a:endParaRPr lang="en-US" sz="1050" dirty="0"/>
+            <a:endParaRPr lang="en-US" sz="1000" dirty="0"/>
           </a:p>
         </p:txBody>
       </p:sp>
@@ -27979,8 +27979,8 @@
         </p:nvSpPr>
         <p:spPr>
           <a:xfrm>
-            <a:off x="10515600" y="438912"/>
-            <a:ext cx="914400" cy="228600"/>
+            <a:off x="10515600" y="329184"/>
+            <a:ext cx="914400" cy="201168"/>
           </a:xfrm>
           <a:prstGeom prst="rect">
             <a:avLst/>
@@ -30386,8 +30386,8 @@
         </p:nvSpPr>
         <p:spPr>
           <a:xfrm>
-            <a:off x="731520" y="384048"/>
-            <a:ext cx="9144000" cy="219456"/>
+            <a:off x="731520" y="329184"/>
+            <a:ext cx="9144000" cy="201168"/>
           </a:xfrm>
           <a:prstGeom prst="rect">
             <a:avLst/>
@@ -30425,24 +30425,24 @@
         </p:nvSpPr>
         <p:spPr>
           <a:xfrm>
-            <a:off x="731520" y="594360"/>
-            <a:ext cx="9601200" cy="438912"/>
-          </a:xfrm>
-          <a:prstGeom prst="rect">
-            <a:avLst/>
-          </a:prstGeom>
-          <a:noFill/>
-          <a:ln/>
-        </p:spPr>
-        <p:txBody>
-          <a:bodyPr wrap="square" rtlCol="0" anchor="ctr"/>
-          <a:lstStyle/>
-          <a:p>
-            <a:pPr indent="0" marL="0">
-              <a:buNone/>
-            </a:pPr>
-            <a:r>
-              <a:rPr lang="en-US" sz="1900" b="1" dirty="0">
+            <a:off x="731520" y="566928"/>
+            <a:ext cx="9601200" cy="402336"/>
+          </a:xfrm>
+          <a:prstGeom prst="rect">
+            <a:avLst/>
+          </a:prstGeom>
+          <a:noFill/>
+          <a:ln/>
+        </p:spPr>
+        <p:txBody>
+          <a:bodyPr wrap="square" rtlCol="0" anchor="ctr"/>
+          <a:lstStyle/>
+          <a:p>
+            <a:pPr indent="0" marL="0">
+              <a:buNone/>
+            </a:pPr>
+            <a:r>
+              <a:rPr lang="en-US" sz="1850" b="1" dirty="0">
                 <a:solidFill>
                   <a:srgbClr val="0F172A"/>
                 </a:solidFill>
@@ -30452,7 +30452,7 @@
               </a:rPr>
               <a:t>PIPELINE 5 TAHAPAN HILIRISASI RISET SOLO TECHNOPARK</a:t>
             </a:r>
-            <a:endParaRPr lang="en-US" sz="1900" dirty="0"/>
+            <a:endParaRPr lang="en-US" sz="1850" dirty="0"/>
           </a:p>
         </p:txBody>
       </p:sp>
@@ -30464,24 +30464,24 @@
         </p:nvSpPr>
         <p:spPr>
           <a:xfrm>
-            <a:off x="731520" y="1024128"/>
-            <a:ext cx="9601200" cy="256032"/>
-          </a:xfrm>
-          <a:prstGeom prst="rect">
-            <a:avLst/>
-          </a:prstGeom>
-          <a:noFill/>
-          <a:ln/>
-        </p:spPr>
-        <p:txBody>
-          <a:bodyPr wrap="square" rtlCol="0" anchor="ctr"/>
-          <a:lstStyle/>
-          <a:p>
-            <a:pPr indent="0" marL="0">
-              <a:buNone/>
-            </a:pPr>
-            <a:r>
-              <a:rPr lang="en-US" sz="1050" i="1" dirty="0">
+            <a:off x="731520" y="1005840"/>
+            <a:ext cx="9601200" cy="237744"/>
+          </a:xfrm>
+          <a:prstGeom prst="rect">
+            <a:avLst/>
+          </a:prstGeom>
+          <a:noFill/>
+          <a:ln/>
+        </p:spPr>
+        <p:txBody>
+          <a:bodyPr wrap="square" rtlCol="0" anchor="ctr"/>
+          <a:lstStyle/>
+          <a:p>
+            <a:pPr indent="0" marL="0">
+              <a:buNone/>
+            </a:pPr>
+            <a:r>
+              <a:rPr lang="en-US" sz="1000" i="1" dirty="0">
                 <a:solidFill>
                   <a:srgbClr val="64748B"/>
                 </a:solidFill>
@@ -30491,7 +30491,7 @@
               </a:rPr>
               <a:t>Mengatasi Valley of Death Inovasi melalui Fasilitasi Terpadu Kesiapan Teknologi TRL 1 hingga TRL 9</a:t>
             </a:r>
-            <a:endParaRPr lang="en-US" sz="1050" dirty="0"/>
+            <a:endParaRPr lang="en-US" sz="1000" dirty="0"/>
           </a:p>
         </p:txBody>
       </p:sp>
@@ -30503,8 +30503,8 @@
         </p:nvSpPr>
         <p:spPr>
           <a:xfrm>
-            <a:off x="10515600" y="438912"/>
-            <a:ext cx="914400" cy="228600"/>
+            <a:off x="10515600" y="329184"/>
+            <a:ext cx="914400" cy="201168"/>
           </a:xfrm>
           <a:prstGeom prst="rect">
             <a:avLst/>
@@ -33509,8 +33509,8 @@
         </p:nvSpPr>
         <p:spPr>
           <a:xfrm>
-            <a:off x="731520" y="384048"/>
-            <a:ext cx="9144000" cy="219456"/>
+            <a:off x="731520" y="329184"/>
+            <a:ext cx="9144000" cy="201168"/>
           </a:xfrm>
           <a:prstGeom prst="rect">
             <a:avLst/>
@@ -33548,24 +33548,24 @@
         </p:nvSpPr>
         <p:spPr>
           <a:xfrm>
-            <a:off x="731520" y="594360"/>
-            <a:ext cx="9601200" cy="438912"/>
-          </a:xfrm>
-          <a:prstGeom prst="rect">
-            <a:avLst/>
-          </a:prstGeom>
-          <a:noFill/>
-          <a:ln/>
-        </p:spPr>
-        <p:txBody>
-          <a:bodyPr wrap="square" rtlCol="0" anchor="ctr"/>
-          <a:lstStyle/>
-          <a:p>
-            <a:pPr indent="0" marL="0">
-              <a:buNone/>
-            </a:pPr>
-            <a:r>
-              <a:rPr lang="en-US" sz="1900" b="1" dirty="0">
+            <a:off x="731520" y="566928"/>
+            <a:ext cx="9601200" cy="402336"/>
+          </a:xfrm>
+          <a:prstGeom prst="rect">
+            <a:avLst/>
+          </a:prstGeom>
+          <a:noFill/>
+          <a:ln/>
+        </p:spPr>
+        <p:txBody>
+          <a:bodyPr wrap="square" rtlCol="0" anchor="ctr"/>
+          <a:lstStyle/>
+          <a:p>
+            <a:pPr indent="0" marL="0">
+              <a:buNone/>
+            </a:pPr>
+            <a:r>
+              <a:rPr lang="en-US" sz="1850" b="1" dirty="0">
                 <a:solidFill>
                   <a:srgbClr val="0F172A"/>
                 </a:solidFill>
@@ -33575,7 +33575,7 @@
               </a:rPr>
               <a:t>SHOWCASE PRODUK HILIRISASI &amp; FASILITAS CANGGIH KAWASAN</a:t>
             </a:r>
-            <a:endParaRPr lang="en-US" sz="1900" dirty="0"/>
+            <a:endParaRPr lang="en-US" sz="1850" dirty="0"/>
           </a:p>
         </p:txBody>
       </p:sp>
@@ -33587,24 +33587,24 @@
         </p:nvSpPr>
         <p:spPr>
           <a:xfrm>
-            <a:off x="731520" y="1024128"/>
-            <a:ext cx="9601200" cy="256032"/>
-          </a:xfrm>
-          <a:prstGeom prst="rect">
-            <a:avLst/>
-          </a:prstGeom>
-          <a:noFill/>
-          <a:ln/>
-        </p:spPr>
-        <p:txBody>
-          <a:bodyPr wrap="square" rtlCol="0" anchor="ctr"/>
-          <a:lstStyle/>
-          <a:p>
-            <a:pPr indent="0" marL="0">
-              <a:buNone/>
-            </a:pPr>
-            <a:r>
-              <a:rPr lang="en-US" sz="1050" i="1" dirty="0">
+            <a:off x="731520" y="1005840"/>
+            <a:ext cx="9601200" cy="237744"/>
+          </a:xfrm>
+          <a:prstGeom prst="rect">
+            <a:avLst/>
+          </a:prstGeom>
+          <a:noFill/>
+          <a:ln/>
+        </p:spPr>
+        <p:txBody>
+          <a:bodyPr wrap="square" rtlCol="0" anchor="ctr"/>
+          <a:lstStyle/>
+          <a:p>
+            <a:pPr indent="0" marL="0">
+              <a:buNone/>
+            </a:pPr>
+            <a:r>
+              <a:rPr lang="en-US" sz="1000" i="1" dirty="0">
                 <a:solidFill>
                   <a:srgbClr val="64748B"/>
                 </a:solidFill>
@@ -33614,7 +33614,7 @@
               </a:rPr>
               <a:t>Bukti Nyata Hasil Riset yang Telah Digunakan Industri dan Infrastruktur Laboratorium Pendukung</a:t>
             </a:r>
-            <a:endParaRPr lang="en-US" sz="1050" dirty="0"/>
+            <a:endParaRPr lang="en-US" sz="1000" dirty="0"/>
           </a:p>
         </p:txBody>
       </p:sp>
@@ -33626,8 +33626,8 @@
         </p:nvSpPr>
         <p:spPr>
           <a:xfrm>
-            <a:off x="10515600" y="438912"/>
-            <a:ext cx="914400" cy="228600"/>
+            <a:off x="10515600" y="329184"/>
+            <a:ext cx="914400" cy="201168"/>
           </a:xfrm>
           <a:prstGeom prst="rect">
             <a:avLst/>
@@ -35869,8 +35869,8 @@
         </p:nvSpPr>
         <p:spPr>
           <a:xfrm>
-            <a:off x="731520" y="384048"/>
-            <a:ext cx="9144000" cy="219456"/>
+            <a:off x="731520" y="329184"/>
+            <a:ext cx="9144000" cy="201168"/>
           </a:xfrm>
           <a:prstGeom prst="rect">
             <a:avLst/>
@@ -35908,24 +35908,24 @@
         </p:nvSpPr>
         <p:spPr>
           <a:xfrm>
-            <a:off x="731520" y="594360"/>
-            <a:ext cx="9601200" cy="438912"/>
-          </a:xfrm>
-          <a:prstGeom prst="rect">
-            <a:avLst/>
-          </a:prstGeom>
-          <a:noFill/>
-          <a:ln/>
-        </p:spPr>
-        <p:txBody>
-          <a:bodyPr wrap="square" rtlCol="0" anchor="ctr"/>
-          <a:lstStyle/>
-          <a:p>
-            <a:pPr indent="0" marL="0">
-              <a:buNone/>
-            </a:pPr>
-            <a:r>
-              <a:rPr lang="en-US" sz="1900" b="1" dirty="0">
+            <a:off x="731520" y="566928"/>
+            <a:ext cx="9601200" cy="402336"/>
+          </a:xfrm>
+          <a:prstGeom prst="rect">
+            <a:avLst/>
+          </a:prstGeom>
+          <a:noFill/>
+          <a:ln/>
+        </p:spPr>
+        <p:txBody>
+          <a:bodyPr wrap="square" rtlCol="0" anchor="ctr"/>
+          <a:lstStyle/>
+          <a:p>
+            <a:pPr indent="0" marL="0">
+              <a:buNone/>
+            </a:pPr>
+            <a:r>
+              <a:rPr lang="en-US" sz="1850" b="1" dirty="0">
                 <a:solidFill>
                   <a:srgbClr val="0F172A"/>
                 </a:solidFill>
@@ -35935,7 +35935,7 @@
               </a:rPr>
               <a:t>EKOSISTEM HEXAHELIX: 95+ MITRA STRATEGIS GLOBAL &amp; NASIONAL</a:t>
             </a:r>
-            <a:endParaRPr lang="en-US" sz="1900" dirty="0"/>
+            <a:endParaRPr lang="en-US" sz="1850" dirty="0"/>
           </a:p>
         </p:txBody>
       </p:sp>
@@ -35947,24 +35947,24 @@
         </p:nvSpPr>
         <p:spPr>
           <a:xfrm>
-            <a:off x="731520" y="1024128"/>
-            <a:ext cx="9601200" cy="256032"/>
-          </a:xfrm>
-          <a:prstGeom prst="rect">
-            <a:avLst/>
-          </a:prstGeom>
-          <a:noFill/>
-          <a:ln/>
-        </p:spPr>
-        <p:txBody>
-          <a:bodyPr wrap="square" rtlCol="0" anchor="ctr"/>
-          <a:lstStyle/>
-          <a:p>
-            <a:pPr indent="0" marL="0">
-              <a:buNone/>
-            </a:pPr>
-            <a:r>
-              <a:rPr lang="en-US" sz="1050" i="1" dirty="0">
+            <a:off x="731520" y="1005840"/>
+            <a:ext cx="9601200" cy="237744"/>
+          </a:xfrm>
+          <a:prstGeom prst="rect">
+            <a:avLst/>
+          </a:prstGeom>
+          <a:noFill/>
+          <a:ln/>
+        </p:spPr>
+        <p:txBody>
+          <a:bodyPr wrap="square" rtlCol="0" anchor="ctr"/>
+          <a:lstStyle/>
+          <a:p>
+            <a:pPr indent="0" marL="0">
+              <a:buNone/>
+            </a:pPr>
+            <a:r>
+              <a:rPr lang="en-US" sz="1000" i="1" dirty="0">
                 <a:solidFill>
                   <a:srgbClr val="64748B"/>
                 </a:solidFill>
@@ -35974,7 +35974,7 @@
               </a:rPr>
               <a:t>Membangun Ekosistem Berkelanjutan Murni Berbasis Kerjasama Tanpa Beban Belanja Modal APBD</a:t>
             </a:r>
-            <a:endParaRPr lang="en-US" sz="1050" dirty="0"/>
+            <a:endParaRPr lang="en-US" sz="1000" dirty="0"/>
           </a:p>
         </p:txBody>
       </p:sp>
@@ -35986,8 +35986,8 @@
         </p:nvSpPr>
         <p:spPr>
           <a:xfrm>
-            <a:off x="10515600" y="438912"/>
-            <a:ext cx="914400" cy="228600"/>
+            <a:off x="10515600" y="329184"/>
+            <a:ext cx="914400" cy="201168"/>
           </a:xfrm>
           <a:prstGeom prst="rect">
             <a:avLst/>
@@ -38365,8 +38365,8 @@
         </p:nvSpPr>
         <p:spPr>
           <a:xfrm>
-            <a:off x="731520" y="384048"/>
-            <a:ext cx="9144000" cy="219456"/>
+            <a:off x="731520" y="329184"/>
+            <a:ext cx="9144000" cy="201168"/>
           </a:xfrm>
           <a:prstGeom prst="rect">
             <a:avLst/>
@@ -38404,24 +38404,24 @@
         </p:nvSpPr>
         <p:spPr>
           <a:xfrm>
-            <a:off x="731520" y="594360"/>
-            <a:ext cx="9601200" cy="438912"/>
-          </a:xfrm>
-          <a:prstGeom prst="rect">
-            <a:avLst/>
-          </a:prstGeom>
-          <a:noFill/>
-          <a:ln/>
-        </p:spPr>
-        <p:txBody>
-          <a:bodyPr wrap="square" rtlCol="0" anchor="ctr"/>
-          <a:lstStyle/>
-          <a:p>
-            <a:pPr indent="0" marL="0">
-              <a:buNone/>
-            </a:pPr>
-            <a:r>
-              <a:rPr lang="en-US" sz="1900" b="1" dirty="0">
+            <a:off x="731520" y="566928"/>
+            <a:ext cx="9601200" cy="402336"/>
+          </a:xfrm>
+          <a:prstGeom prst="rect">
+            <a:avLst/>
+          </a:prstGeom>
+          <a:noFill/>
+          <a:ln/>
+        </p:spPr>
+        <p:txBody>
+          <a:bodyPr wrap="square" rtlCol="0" anchor="ctr"/>
+          <a:lstStyle/>
+          <a:p>
+            <a:pPr indent="0" marL="0">
+              <a:buNone/>
+            </a:pPr>
+            <a:r>
+              <a:rPr lang="en-US" sz="1850" b="1" dirty="0">
                 <a:solidFill>
                   <a:srgbClr val="0F172A"/>
                 </a:solidFill>
@@ -38431,7 +38431,7 @@
               </a:rPr>
               <a:t>DIAGNOSA 5 GAP STRUKTURAL &amp; BOTTLENECK EKSISTING STP</a:t>
             </a:r>
-            <a:endParaRPr lang="en-US" sz="1900" dirty="0"/>
+            <a:endParaRPr lang="en-US" sz="1850" dirty="0"/>
           </a:p>
         </p:txBody>
       </p:sp>
@@ -38443,24 +38443,24 @@
         </p:nvSpPr>
         <p:spPr>
           <a:xfrm>
-            <a:off x="731520" y="1024128"/>
-            <a:ext cx="9601200" cy="256032"/>
-          </a:xfrm>
-          <a:prstGeom prst="rect">
-            <a:avLst/>
-          </a:prstGeom>
-          <a:noFill/>
-          <a:ln/>
-        </p:spPr>
-        <p:txBody>
-          <a:bodyPr wrap="square" rtlCol="0" anchor="ctr"/>
-          <a:lstStyle/>
-          <a:p>
-            <a:pPr indent="0" marL="0">
-              <a:buNone/>
-            </a:pPr>
-            <a:r>
-              <a:rPr lang="en-US" sz="1050" i="1" dirty="0">
+            <a:off x="731520" y="1005840"/>
+            <a:ext cx="9601200" cy="237744"/>
+          </a:xfrm>
+          <a:prstGeom prst="rect">
+            <a:avLst/>
+          </a:prstGeom>
+          <a:noFill/>
+          <a:ln/>
+        </p:spPr>
+        <p:txBody>
+          <a:bodyPr wrap="square" rtlCol="0" anchor="ctr"/>
+          <a:lstStyle/>
+          <a:p>
+            <a:pPr indent="0" marL="0">
+              <a:buNone/>
+            </a:pPr>
+            <a:r>
+              <a:rPr lang="en-US" sz="1000" i="1" dirty="0">
                 <a:solidFill>
                   <a:srgbClr val="64748B"/>
                 </a:solidFill>
@@ -38470,7 +38470,7 @@
               </a:rPr>
               <a:t>Identifikasi Hambatan Utama yang Menahan Akselerasi Kemandirian dan Optimalisasi Dampak STP</a:t>
             </a:r>
-            <a:endParaRPr lang="en-US" sz="1050" dirty="0"/>
+            <a:endParaRPr lang="en-US" sz="1000" dirty="0"/>
           </a:p>
         </p:txBody>
       </p:sp>
@@ -38482,8 +38482,8 @@
         </p:nvSpPr>
         <p:spPr>
           <a:xfrm>
-            <a:off x="10515600" y="438912"/>
-            <a:ext cx="914400" cy="228600"/>
+            <a:off x="10515600" y="329184"/>
+            <a:ext cx="914400" cy="201168"/>
           </a:xfrm>
           <a:prstGeom prst="rect">
             <a:avLst/>

</xml_diff>